<commit_message>
Updated progress seminar presentation
</commit_message>
<xml_diff>
--- a/Progress Seminar/Privacy-Preserving Federated Learning for Distributed Skin Disease Classification.pptx
+++ b/Progress Seminar/Privacy-Preserving Federated Learning for Distributed Skin Disease Classification.pptx
@@ -5,26 +5,32 @@
     <p:sldMasterId id="2147483648" r:id="rId4"/>
   </p:sldMasterIdLst>
   <p:notesMasterIdLst>
-    <p:notesMasterId r:id="rId14"/>
+    <p:notesMasterId r:id="rId20"/>
   </p:notesMasterIdLst>
   <p:handoutMasterIdLst>
-    <p:handoutMasterId r:id="rId15"/>
+    <p:handoutMasterId r:id="rId21"/>
   </p:handoutMasterIdLst>
   <p:sldIdLst>
-    <p:sldId id="374" r:id="rId5"/>
-    <p:sldId id="377" r:id="rId6"/>
+    <p:sldId id="456" r:id="rId5"/>
+    <p:sldId id="457" r:id="rId6"/>
     <p:sldId id="437" r:id="rId7"/>
     <p:sldId id="381" r:id="rId8"/>
     <p:sldId id="442" r:id="rId9"/>
     <p:sldId id="443" r:id="rId10"/>
     <p:sldId id="446" r:id="rId11"/>
     <p:sldId id="441" r:id="rId12"/>
-    <p:sldId id="447" r:id="rId13"/>
+    <p:sldId id="448" r:id="rId13"/>
+    <p:sldId id="455" r:id="rId14"/>
+    <p:sldId id="449" r:id="rId15"/>
+    <p:sldId id="450" r:id="rId16"/>
+    <p:sldId id="453" r:id="rId17"/>
+    <p:sldId id="454" r:id="rId18"/>
+    <p:sldId id="458" r:id="rId19"/>
   </p:sldIdLst>
   <p:sldSz cx="12192000" cy="6858000"/>
   <p:notesSz cx="6858000" cy="9144000"/>
   <p:custDataLst>
-    <p:tags r:id="rId16"/>
+    <p:tags r:id="rId22"/>
   </p:custDataLst>
   <p:defaultTextStyle>
     <a:defPPr>
@@ -225,7 +231,7 @@
           <a:p>
             <a:fld id="{412A36AD-C140-47B5-A0AA-2808AF1C1C9D}" type="datetimeFigureOut">
               <a:rPr lang="en-AU" smtClean="0"/>
-              <a:t>8/05/2026</a:t>
+              <a:t>9/05/2026</a:t>
             </a:fld>
             <a:endParaRPr lang="en-AU"/>
           </a:p>
@@ -390,7 +396,7 @@
           <a:p>
             <a:fld id="{2763829E-EB69-4A98-9D54-8D6822520B27}" type="datetimeFigureOut">
               <a:rPr lang="en-AU" smtClean="0"/>
-              <a:t>8/05/2026</a:t>
+              <a:t>9/05/2026</a:t>
             </a:fld>
             <a:endParaRPr lang="en-AU"/>
           </a:p>
@@ -23519,10 +23525,10 @@
       </p:grpSpPr>
       <p:sp>
         <p:nvSpPr>
-          <p:cNvPr id="3" name="Title 2">
-            <a:extLst>
-              <a:ext uri="{FF2B5EF4-FFF2-40B4-BE49-F238E27FC236}">
-                <a16:creationId xmlns:a16="http://schemas.microsoft.com/office/drawing/2014/main" id="{A7415914-B0F2-426D-AA44-7C1F712B27E1}"/>
+          <p:cNvPr id="2" name="Title 1">
+            <a:extLst>
+              <a:ext uri="{FF2B5EF4-FFF2-40B4-BE49-F238E27FC236}">
+                <a16:creationId xmlns:a16="http://schemas.microsoft.com/office/drawing/2014/main" id="{BA2BD245-ED11-9F03-6B26-A481A2BF5921}"/>
               </a:ext>
             </a:extLst>
           </p:cNvPr>
@@ -23533,25 +23539,30 @@
             <p:ph type="title"/>
           </p:nvPr>
         </p:nvSpPr>
-        <p:spPr/>
+        <p:spPr>
+          <a:xfrm>
+            <a:off x="479424" y="1539976"/>
+            <a:ext cx="7920831" cy="1096862"/>
+          </a:xfrm>
+        </p:spPr>
         <p:txBody>
           <a:bodyPr/>
           <a:lstStyle/>
           <a:p>
             <a:r>
-              <a:rPr lang="en-US" sz="2400" dirty="0"/>
+              <a:rPr lang="en-US" sz="3600" dirty="0"/>
               <a:t>Privacy-Preserving Federated Learning for Distributed Skin Disease Classification</a:t>
             </a:r>
-            <a:endParaRPr lang="en-AU" sz="2400" dirty="0"/>
-          </a:p>
-        </p:txBody>
-      </p:sp>
-      <p:sp>
-        <p:nvSpPr>
-          <p:cNvPr id="4" name="Text Placeholder 3">
-            <a:extLst>
-              <a:ext uri="{FF2B5EF4-FFF2-40B4-BE49-F238E27FC236}">
-                <a16:creationId xmlns:a16="http://schemas.microsoft.com/office/drawing/2014/main" id="{F825BCEC-EFFB-497F-B9B3-B96601F0F078}"/>
+            <a:endParaRPr lang="en-AU" sz="3600" dirty="0"/>
+          </a:p>
+        </p:txBody>
+      </p:sp>
+      <p:sp>
+        <p:nvSpPr>
+          <p:cNvPr id="3" name="Text Placeholder 2">
+            <a:extLst>
+              <a:ext uri="{FF2B5EF4-FFF2-40B4-BE49-F238E27FC236}">
+                <a16:creationId xmlns:a16="http://schemas.microsoft.com/office/drawing/2014/main" id="{26D46013-99C6-C481-8819-4AEFD5F9F9AF}"/>
               </a:ext>
             </a:extLst>
           </p:cNvPr>
@@ -23562,12 +23573,7 @@
             <p:ph type="body" sz="quarter" idx="10"/>
           </p:nvPr>
         </p:nvSpPr>
-        <p:spPr>
-          <a:xfrm>
-            <a:off x="499203" y="4365104"/>
-            <a:ext cx="5020733" cy="644057"/>
-          </a:xfrm>
-        </p:spPr>
+        <p:spPr/>
         <p:txBody>
           <a:bodyPr/>
           <a:lstStyle/>
@@ -23580,902 +23586,43 @@
           <a:p>
             <a:r>
               <a:rPr lang="en-AU" dirty="0"/>
-              <a:t>Supervised by </a:t>
-            </a:r>
-          </a:p>
-          <a:p>
-            <a:r>
-              <a:rPr lang="en-AU" dirty="0"/>
-              <a:t>Ruihong Qiu and Helen Huang</a:t>
-            </a:r>
-          </a:p>
-        </p:txBody>
-      </p:sp>
-      <p:pic>
-        <p:nvPicPr>
-          <p:cNvPr id="7" name="Picture Placeholder 6">
-            <a:extLst>
-              <a:ext uri="{FF2B5EF4-FFF2-40B4-BE49-F238E27FC236}">
-                <a16:creationId xmlns:a16="http://schemas.microsoft.com/office/drawing/2014/main" id="{5ABA7F1E-3791-4BE9-8BF0-D6B09694A4AC}"/>
-              </a:ext>
-            </a:extLst>
-          </p:cNvPr>
-          <p:cNvPicPr>
-            <a:picLocks noGrp="1" noChangeAspect="1"/>
-          </p:cNvPicPr>
-          <p:nvPr>
-            <p:ph type="pic" sz="quarter" idx="12"/>
-          </p:nvPr>
-        </p:nvPicPr>
-        <p:blipFill rotWithShape="1">
-          <a:blip r:embed="rId2" cstate="print">
-            <a:extLst>
-              <a:ext uri="{28A0092B-C50C-407E-A947-70E740481C1C}">
-                <a14:useLocalDpi xmlns:a14="http://schemas.microsoft.com/office/drawing/2010/main"/>
-              </a:ext>
-            </a:extLst>
-          </a:blip>
-          <a:srcRect/>
-          <a:stretch>
-            <a:fillRect/>
-          </a:stretch>
-        </p:blipFill>
-        <p:spPr>
-          <a:xfrm>
-            <a:off x="5335585" y="0"/>
-            <a:ext cx="6856415" cy="6858003"/>
-          </a:xfrm>
-        </p:spPr>
-      </p:pic>
-      <p:sp>
-        <p:nvSpPr>
-          <p:cNvPr id="15" name="TextBox 14">
-            <a:extLst>
-              <a:ext uri="{FF2B5EF4-FFF2-40B4-BE49-F238E27FC236}">
-                <a16:creationId xmlns:a16="http://schemas.microsoft.com/office/drawing/2014/main" id="{2CE55737-D773-9322-5688-61A6F6D73387}"/>
-              </a:ext>
-            </a:extLst>
-          </p:cNvPr>
-          <p:cNvSpPr txBox="1"/>
-          <p:nvPr/>
-        </p:nvSpPr>
-        <p:spPr bwMode="gray">
-          <a:xfrm>
-            <a:off x="-2400944" y="33844"/>
-            <a:ext cx="2080959" cy="3046988"/>
-          </a:xfrm>
-          <a:prstGeom prst="rect">
-            <a:avLst/>
-          </a:prstGeom>
-          <a:noFill/>
-        </p:spPr>
-        <p:txBody>
-          <a:bodyPr wrap="square" lIns="0" tIns="0" rIns="0" bIns="0" rtlCol="0">
-            <a:spAutoFit/>
-          </a:bodyPr>
+              <a:t>Supervised by Ruihong Qiu and Zi (Helen) Huang</a:t>
+            </a:r>
+          </a:p>
+          <a:p>
+            <a:endParaRPr lang="en-AU" dirty="0"/>
+          </a:p>
+        </p:txBody>
+      </p:sp>
+      <p:sp>
+        <p:nvSpPr>
+          <p:cNvPr id="4" name="Text Placeholder 3">
+            <a:extLst>
+              <a:ext uri="{FF2B5EF4-FFF2-40B4-BE49-F238E27FC236}">
+                <a16:creationId xmlns:a16="http://schemas.microsoft.com/office/drawing/2014/main" id="{D510A407-798A-92B2-82A9-166ECCB4E62E}"/>
+              </a:ext>
+            </a:extLst>
+          </p:cNvPr>
+          <p:cNvSpPr>
+            <a:spLocks noGrp="1"/>
+          </p:cNvSpPr>
+          <p:nvPr>
+            <p:ph type="body" sz="quarter" idx="11"/>
+          </p:nvPr>
+        </p:nvSpPr>
+        <p:spPr/>
+        <p:txBody>
+          <a:bodyPr/>
           <a:lstStyle/>
           <a:p>
-            <a:pPr marL="0" indent="0">
-              <a:buFont typeface="Arial" panose="020B0604020202020204" pitchFamily="34" charset="0"/>
-              <a:buNone/>
-            </a:pPr>
-            <a:r>
-              <a:rPr lang="en-AU" sz="1100" dirty="0">
-                <a:solidFill>
-                  <a:srgbClr val="000000"/>
-                </a:solidFill>
-              </a:rPr>
-              <a:t>Inserting an image</a:t>
-            </a:r>
-          </a:p>
-          <a:p>
-            <a:pPr marL="171450" indent="-171450">
-              <a:buFont typeface="Arial" panose="020B0604020202020204" pitchFamily="34" charset="0"/>
-              <a:buChar char="•"/>
-            </a:pPr>
-            <a:r>
-              <a:rPr lang="en-AU" sz="1100" dirty="0">
-                <a:solidFill>
-                  <a:srgbClr val="000000"/>
-                </a:solidFill>
-              </a:rPr>
-              <a:t>You can easily drop in a new image by selecting a placeholder and dragging an image onto it (or press the “insert image” icon in the middle of the placeholder. </a:t>
-            </a:r>
-          </a:p>
-          <a:p>
-            <a:pPr marL="171450" indent="-171450">
-              <a:buFont typeface="Arial" panose="020B0604020202020204" pitchFamily="34" charset="0"/>
-              <a:buChar char="•"/>
-            </a:pPr>
-            <a:r>
-              <a:rPr lang="en-AU" sz="1100" dirty="0">
-                <a:solidFill>
-                  <a:srgbClr val="000000"/>
-                </a:solidFill>
-              </a:rPr>
-              <a:t>Then be sure to right click and select ‘send to back’. </a:t>
-            </a:r>
-          </a:p>
-          <a:p>
-            <a:endParaRPr lang="en-AU" sz="1100" dirty="0">
-              <a:solidFill>
-                <a:srgbClr val="000000"/>
-              </a:solidFill>
-            </a:endParaRPr>
-          </a:p>
-          <a:p>
-            <a:r>
-              <a:rPr lang="en-AU" sz="1100" dirty="0">
-                <a:solidFill>
-                  <a:srgbClr val="000000"/>
-                </a:solidFill>
-              </a:rPr>
-              <a:t>To replace an image on a populated slide</a:t>
-            </a:r>
-          </a:p>
-          <a:p>
-            <a:pPr marL="171450" indent="-171450">
-              <a:buFont typeface="Arial" panose="020B0604020202020204" pitchFamily="34" charset="0"/>
-              <a:buChar char="•"/>
-            </a:pPr>
-            <a:r>
-              <a:rPr lang="en-AU" sz="1100" dirty="0">
-                <a:solidFill>
-                  <a:srgbClr val="000000"/>
-                </a:solidFill>
-              </a:rPr>
-              <a:t>Click Reset on the Home tab</a:t>
-            </a:r>
-          </a:p>
-          <a:p>
-            <a:pPr marL="171450" indent="-171450">
-              <a:buFont typeface="Arial" panose="020B0604020202020204" pitchFamily="34" charset="0"/>
-              <a:buChar char="•"/>
-            </a:pPr>
-            <a:r>
-              <a:rPr lang="en-AU" sz="1100" dirty="0">
-                <a:solidFill>
-                  <a:srgbClr val="000000"/>
-                </a:solidFill>
-              </a:rPr>
-              <a:t>Delete the existing image</a:t>
-            </a:r>
-          </a:p>
-          <a:p>
-            <a:pPr marL="171450" indent="-171450">
-              <a:buFont typeface="Arial" panose="020B0604020202020204" pitchFamily="34" charset="0"/>
-              <a:buChar char="•"/>
-            </a:pPr>
-            <a:r>
-              <a:rPr lang="en-AU" sz="1100" dirty="0">
-                <a:solidFill>
-                  <a:srgbClr val="000000"/>
-                </a:solidFill>
-              </a:rPr>
-              <a:t>Click icon to insert a new image </a:t>
-            </a:r>
-          </a:p>
-          <a:p>
-            <a:pPr marL="171450" indent="-171450">
-              <a:buFont typeface="Arial" panose="020B0604020202020204" pitchFamily="34" charset="0"/>
-              <a:buChar char="•"/>
-            </a:pPr>
-            <a:r>
-              <a:rPr lang="en-AU" sz="1100" dirty="0">
-                <a:solidFill>
-                  <a:srgbClr val="000000"/>
-                </a:solidFill>
-              </a:rPr>
-              <a:t>Right click and choose “send to back”</a:t>
-            </a:r>
-          </a:p>
-        </p:txBody>
-      </p:sp>
-      <p:grpSp>
-        <p:nvGrpSpPr>
-          <p:cNvPr id="16" name="Group 15">
-            <a:extLst>
-              <a:ext uri="{FF2B5EF4-FFF2-40B4-BE49-F238E27FC236}">
-                <a16:creationId xmlns:a16="http://schemas.microsoft.com/office/drawing/2014/main" id="{51EF6D69-ADD9-40E1-4746-EC155C9028FB}"/>
-              </a:ext>
-            </a:extLst>
-          </p:cNvPr>
-          <p:cNvGrpSpPr>
-            <a:grpSpLocks noChangeAspect="1"/>
-          </p:cNvGrpSpPr>
-          <p:nvPr/>
-        </p:nvGrpSpPr>
-        <p:grpSpPr bwMode="gray">
-          <a:xfrm>
-            <a:off x="-2933683" y="161872"/>
-            <a:ext cx="335767" cy="274418"/>
-            <a:chOff x="431" y="79"/>
-            <a:chExt cx="4882" cy="3990"/>
-          </a:xfrm>
-          <a:solidFill>
-            <a:schemeClr val="accent1"/>
-          </a:solidFill>
-        </p:grpSpPr>
-        <p:sp>
-          <p:nvSpPr>
-            <p:cNvPr id="17" name="Oval 9">
-              <a:extLst>
-                <a:ext uri="{FF2B5EF4-FFF2-40B4-BE49-F238E27FC236}">
-                  <a16:creationId xmlns:a16="http://schemas.microsoft.com/office/drawing/2014/main" id="{A0D1ECC1-62DF-8DBC-4CCE-CB0B16CE03BD}"/>
-                </a:ext>
-              </a:extLst>
-            </p:cNvPr>
-            <p:cNvSpPr>
-              <a:spLocks noChangeArrowheads="1"/>
-            </p:cNvSpPr>
-            <p:nvPr/>
-          </p:nvSpPr>
-          <p:spPr bwMode="gray">
-            <a:xfrm>
-              <a:off x="1895" y="1299"/>
-              <a:ext cx="1953" cy="1952"/>
-            </a:xfrm>
-            <a:prstGeom prst="ellipse">
-              <a:avLst/>
-            </a:prstGeom>
-            <a:grpFill/>
-            <a:ln>
-              <a:noFill/>
-            </a:ln>
-            <a:extLst>
-              <a:ext uri="{91240B29-F687-4F45-9708-019B960494DF}">
-                <a14:hiddenLine xmlns:a14="http://schemas.microsoft.com/office/drawing/2010/main" w="9525">
-                  <a:solidFill>
-                    <a:srgbClr val="000000"/>
-                  </a:solidFill>
-                  <a:round/>
-                  <a:headEnd/>
-                  <a:tailEnd/>
-                </a14:hiddenLine>
-              </a:ext>
-            </a:extLst>
-          </p:spPr>
-          <p:txBody>
-            <a:bodyPr vert="horz" wrap="square" lIns="91440" tIns="45720" rIns="91440" bIns="45720" numCol="1" anchor="t" anchorCtr="0" compatLnSpc="1">
-              <a:prstTxWarp prst="textNoShape">
-                <a:avLst/>
-              </a:prstTxWarp>
-            </a:bodyPr>
-            <a:lstStyle/>
-            <a:p>
-              <a:endParaRPr lang="en-GB"/>
-            </a:p>
-          </p:txBody>
-        </p:sp>
-        <p:sp>
-          <p:nvSpPr>
-            <p:cNvPr id="18" name="Freeform 10">
-              <a:extLst>
-                <a:ext uri="{FF2B5EF4-FFF2-40B4-BE49-F238E27FC236}">
-                  <a16:creationId xmlns:a16="http://schemas.microsoft.com/office/drawing/2014/main" id="{24604BE0-96BC-61EF-D44A-E06C15FDC0C8}"/>
-                </a:ext>
-              </a:extLst>
-            </p:cNvPr>
-            <p:cNvSpPr>
-              <a:spLocks noEditPoints="1"/>
-            </p:cNvSpPr>
-            <p:nvPr/>
-          </p:nvSpPr>
-          <p:spPr bwMode="gray">
-            <a:xfrm>
-              <a:off x="431" y="79"/>
-              <a:ext cx="4882" cy="3990"/>
-            </a:xfrm>
-            <a:custGeom>
-              <a:avLst/>
-              <a:gdLst>
-                <a:gd name="T0" fmla="*/ 736 w 800"/>
-                <a:gd name="T1" fmla="*/ 134 h 654"/>
-                <a:gd name="T2" fmla="*/ 622 w 800"/>
-                <a:gd name="T3" fmla="*/ 134 h 654"/>
-                <a:gd name="T4" fmla="*/ 569 w 800"/>
-                <a:gd name="T5" fmla="*/ 0 h 654"/>
-                <a:gd name="T6" fmla="*/ 231 w 800"/>
-                <a:gd name="T7" fmla="*/ 0 h 654"/>
-                <a:gd name="T8" fmla="*/ 178 w 800"/>
-                <a:gd name="T9" fmla="*/ 134 h 654"/>
-                <a:gd name="T10" fmla="*/ 160 w 800"/>
-                <a:gd name="T11" fmla="*/ 134 h 654"/>
-                <a:gd name="T12" fmla="*/ 160 w 800"/>
-                <a:gd name="T13" fmla="*/ 67 h 654"/>
-                <a:gd name="T14" fmla="*/ 80 w 800"/>
-                <a:gd name="T15" fmla="*/ 67 h 654"/>
-                <a:gd name="T16" fmla="*/ 80 w 800"/>
-                <a:gd name="T17" fmla="*/ 134 h 654"/>
-                <a:gd name="T18" fmla="*/ 64 w 800"/>
-                <a:gd name="T19" fmla="*/ 134 h 654"/>
-                <a:gd name="T20" fmla="*/ 0 w 800"/>
-                <a:gd name="T21" fmla="*/ 198 h 654"/>
-                <a:gd name="T22" fmla="*/ 0 w 800"/>
-                <a:gd name="T23" fmla="*/ 589 h 654"/>
-                <a:gd name="T24" fmla="*/ 64 w 800"/>
-                <a:gd name="T25" fmla="*/ 654 h 654"/>
-                <a:gd name="T26" fmla="*/ 736 w 800"/>
-                <a:gd name="T27" fmla="*/ 654 h 654"/>
-                <a:gd name="T28" fmla="*/ 800 w 800"/>
-                <a:gd name="T29" fmla="*/ 589 h 654"/>
-                <a:gd name="T30" fmla="*/ 800 w 800"/>
-                <a:gd name="T31" fmla="*/ 198 h 654"/>
-                <a:gd name="T32" fmla="*/ 736 w 800"/>
-                <a:gd name="T33" fmla="*/ 134 h 654"/>
-                <a:gd name="T34" fmla="*/ 133 w 800"/>
-                <a:gd name="T35" fmla="*/ 134 h 654"/>
-                <a:gd name="T36" fmla="*/ 107 w 800"/>
-                <a:gd name="T37" fmla="*/ 134 h 654"/>
-                <a:gd name="T38" fmla="*/ 107 w 800"/>
-                <a:gd name="T39" fmla="*/ 94 h 654"/>
-                <a:gd name="T40" fmla="*/ 133 w 800"/>
-                <a:gd name="T41" fmla="*/ 94 h 654"/>
-                <a:gd name="T42" fmla="*/ 133 w 800"/>
-                <a:gd name="T43" fmla="*/ 134 h 654"/>
-                <a:gd name="T44" fmla="*/ 400 w 800"/>
-                <a:gd name="T45" fmla="*/ 600 h 654"/>
-                <a:gd name="T46" fmla="*/ 160 w 800"/>
-                <a:gd name="T47" fmla="*/ 360 h 654"/>
-                <a:gd name="T48" fmla="*/ 400 w 800"/>
-                <a:gd name="T49" fmla="*/ 120 h 654"/>
-                <a:gd name="T50" fmla="*/ 640 w 800"/>
-                <a:gd name="T51" fmla="*/ 360 h 654"/>
-                <a:gd name="T52" fmla="*/ 400 w 800"/>
-                <a:gd name="T53" fmla="*/ 600 h 654"/>
-                <a:gd name="T54" fmla="*/ 693 w 800"/>
-                <a:gd name="T55" fmla="*/ 294 h 654"/>
-                <a:gd name="T56" fmla="*/ 640 w 800"/>
-                <a:gd name="T57" fmla="*/ 240 h 654"/>
-                <a:gd name="T58" fmla="*/ 693 w 800"/>
-                <a:gd name="T59" fmla="*/ 187 h 654"/>
-                <a:gd name="T60" fmla="*/ 747 w 800"/>
-                <a:gd name="T61" fmla="*/ 240 h 654"/>
-                <a:gd name="T62" fmla="*/ 693 w 800"/>
-                <a:gd name="T63" fmla="*/ 294 h 654"/>
-              </a:gdLst>
-              <a:ahLst/>
-              <a:cxnLst>
-                <a:cxn ang="0">
-                  <a:pos x="T0" y="T1"/>
-                </a:cxn>
-                <a:cxn ang="0">
-                  <a:pos x="T2" y="T3"/>
-                </a:cxn>
-                <a:cxn ang="0">
-                  <a:pos x="T4" y="T5"/>
-                </a:cxn>
-                <a:cxn ang="0">
-                  <a:pos x="T6" y="T7"/>
-                </a:cxn>
-                <a:cxn ang="0">
-                  <a:pos x="T8" y="T9"/>
-                </a:cxn>
-                <a:cxn ang="0">
-                  <a:pos x="T10" y="T11"/>
-                </a:cxn>
-                <a:cxn ang="0">
-                  <a:pos x="T12" y="T13"/>
-                </a:cxn>
-                <a:cxn ang="0">
-                  <a:pos x="T14" y="T15"/>
-                </a:cxn>
-                <a:cxn ang="0">
-                  <a:pos x="T16" y="T17"/>
-                </a:cxn>
-                <a:cxn ang="0">
-                  <a:pos x="T18" y="T19"/>
-                </a:cxn>
-                <a:cxn ang="0">
-                  <a:pos x="T20" y="T21"/>
-                </a:cxn>
-                <a:cxn ang="0">
-                  <a:pos x="T22" y="T23"/>
-                </a:cxn>
-                <a:cxn ang="0">
-                  <a:pos x="T24" y="T25"/>
-                </a:cxn>
-                <a:cxn ang="0">
-                  <a:pos x="T26" y="T27"/>
-                </a:cxn>
-                <a:cxn ang="0">
-                  <a:pos x="T28" y="T29"/>
-                </a:cxn>
-                <a:cxn ang="0">
-                  <a:pos x="T30" y="T31"/>
-                </a:cxn>
-                <a:cxn ang="0">
-                  <a:pos x="T32" y="T33"/>
-                </a:cxn>
-                <a:cxn ang="0">
-                  <a:pos x="T34" y="T35"/>
-                </a:cxn>
-                <a:cxn ang="0">
-                  <a:pos x="T36" y="T37"/>
-                </a:cxn>
-                <a:cxn ang="0">
-                  <a:pos x="T38" y="T39"/>
-                </a:cxn>
-                <a:cxn ang="0">
-                  <a:pos x="T40" y="T41"/>
-                </a:cxn>
-                <a:cxn ang="0">
-                  <a:pos x="T42" y="T43"/>
-                </a:cxn>
-                <a:cxn ang="0">
-                  <a:pos x="T44" y="T45"/>
-                </a:cxn>
-                <a:cxn ang="0">
-                  <a:pos x="T46" y="T47"/>
-                </a:cxn>
-                <a:cxn ang="0">
-                  <a:pos x="T48" y="T49"/>
-                </a:cxn>
-                <a:cxn ang="0">
-                  <a:pos x="T50" y="T51"/>
-                </a:cxn>
-                <a:cxn ang="0">
-                  <a:pos x="T52" y="T53"/>
-                </a:cxn>
-                <a:cxn ang="0">
-                  <a:pos x="T54" y="T55"/>
-                </a:cxn>
-                <a:cxn ang="0">
-                  <a:pos x="T56" y="T57"/>
-                </a:cxn>
-                <a:cxn ang="0">
-                  <a:pos x="T58" y="T59"/>
-                </a:cxn>
-                <a:cxn ang="0">
-                  <a:pos x="T60" y="T61"/>
-                </a:cxn>
-                <a:cxn ang="0">
-                  <a:pos x="T62" y="T63"/>
-                </a:cxn>
-              </a:cxnLst>
-              <a:rect l="0" t="0" r="r" b="b"/>
-              <a:pathLst>
-                <a:path w="800" h="654">
-                  <a:moveTo>
-                    <a:pt x="736" y="134"/>
-                  </a:moveTo>
-                  <a:lnTo>
-                    <a:pt x="622" y="134"/>
-                  </a:lnTo>
-                  <a:lnTo>
-                    <a:pt x="569" y="0"/>
-                  </a:lnTo>
-                  <a:lnTo>
-                    <a:pt x="231" y="0"/>
-                  </a:lnTo>
-                  <a:lnTo>
-                    <a:pt x="178" y="134"/>
-                  </a:lnTo>
-                  <a:lnTo>
-                    <a:pt x="160" y="134"/>
-                  </a:lnTo>
-                  <a:lnTo>
-                    <a:pt x="160" y="67"/>
-                  </a:lnTo>
-                  <a:lnTo>
-                    <a:pt x="80" y="67"/>
-                  </a:lnTo>
-                  <a:lnTo>
-                    <a:pt x="80" y="134"/>
-                  </a:lnTo>
-                  <a:lnTo>
-                    <a:pt x="64" y="134"/>
-                  </a:lnTo>
-                  <a:cubicBezTo>
-                    <a:pt x="29" y="134"/>
-                    <a:pt x="0" y="162"/>
-                    <a:pt x="0" y="198"/>
-                  </a:cubicBezTo>
-                  <a:lnTo>
-                    <a:pt x="0" y="589"/>
-                  </a:lnTo>
-                  <a:cubicBezTo>
-                    <a:pt x="0" y="625"/>
-                    <a:pt x="29" y="654"/>
-                    <a:pt x="64" y="654"/>
-                  </a:cubicBezTo>
-                  <a:lnTo>
-                    <a:pt x="736" y="654"/>
-                  </a:lnTo>
-                  <a:cubicBezTo>
-                    <a:pt x="771" y="654"/>
-                    <a:pt x="800" y="625"/>
-                    <a:pt x="800" y="589"/>
-                  </a:cubicBezTo>
-                  <a:lnTo>
-                    <a:pt x="800" y="198"/>
-                  </a:lnTo>
-                  <a:cubicBezTo>
-                    <a:pt x="800" y="162"/>
-                    <a:pt x="771" y="134"/>
-                    <a:pt x="736" y="134"/>
-                  </a:cubicBezTo>
-                  <a:close/>
-                  <a:moveTo>
-                    <a:pt x="133" y="134"/>
-                  </a:moveTo>
-                  <a:lnTo>
-                    <a:pt x="107" y="134"/>
-                  </a:lnTo>
-                  <a:lnTo>
-                    <a:pt x="107" y="94"/>
-                  </a:lnTo>
-                  <a:lnTo>
-                    <a:pt x="133" y="94"/>
-                  </a:lnTo>
-                  <a:lnTo>
-                    <a:pt x="133" y="134"/>
-                  </a:lnTo>
-                  <a:close/>
-                  <a:moveTo>
-                    <a:pt x="400" y="600"/>
-                  </a:moveTo>
-                  <a:cubicBezTo>
-                    <a:pt x="268" y="600"/>
-                    <a:pt x="160" y="493"/>
-                    <a:pt x="160" y="360"/>
-                  </a:cubicBezTo>
-                  <a:cubicBezTo>
-                    <a:pt x="160" y="228"/>
-                    <a:pt x="268" y="120"/>
-                    <a:pt x="400" y="120"/>
-                  </a:cubicBezTo>
-                  <a:cubicBezTo>
-                    <a:pt x="532" y="120"/>
-                    <a:pt x="640" y="228"/>
-                    <a:pt x="640" y="360"/>
-                  </a:cubicBezTo>
-                  <a:cubicBezTo>
-                    <a:pt x="640" y="493"/>
-                    <a:pt x="532" y="600"/>
-                    <a:pt x="400" y="600"/>
-                  </a:cubicBezTo>
-                  <a:close/>
-                  <a:moveTo>
-                    <a:pt x="693" y="294"/>
-                  </a:moveTo>
-                  <a:cubicBezTo>
-                    <a:pt x="664" y="294"/>
-                    <a:pt x="640" y="270"/>
-                    <a:pt x="640" y="240"/>
-                  </a:cubicBezTo>
-                  <a:cubicBezTo>
-                    <a:pt x="640" y="211"/>
-                    <a:pt x="664" y="187"/>
-                    <a:pt x="693" y="187"/>
-                  </a:cubicBezTo>
-                  <a:cubicBezTo>
-                    <a:pt x="723" y="187"/>
-                    <a:pt x="747" y="211"/>
-                    <a:pt x="747" y="240"/>
-                  </a:cubicBezTo>
-                  <a:cubicBezTo>
-                    <a:pt x="747" y="270"/>
-                    <a:pt x="723" y="294"/>
-                    <a:pt x="693" y="294"/>
-                  </a:cubicBezTo>
-                  <a:close/>
-                </a:path>
-              </a:pathLst>
-            </a:custGeom>
-            <a:grpFill/>
-            <a:ln>
-              <a:noFill/>
-            </a:ln>
-            <a:extLst>
-              <a:ext uri="{91240B29-F687-4F45-9708-019B960494DF}">
-                <a14:hiddenLine xmlns:a14="http://schemas.microsoft.com/office/drawing/2010/main" w="9525">
-                  <a:solidFill>
-                    <a:srgbClr val="000000"/>
-                  </a:solidFill>
-                  <a:round/>
-                  <a:headEnd/>
-                  <a:tailEnd/>
-                </a14:hiddenLine>
-              </a:ext>
-            </a:extLst>
-          </p:spPr>
-          <p:txBody>
-            <a:bodyPr vert="horz" wrap="square" lIns="91440" tIns="45720" rIns="91440" bIns="45720" numCol="1" anchor="t" anchorCtr="0" compatLnSpc="1">
-              <a:prstTxWarp prst="textNoShape">
-                <a:avLst/>
-              </a:prstTxWarp>
-            </a:bodyPr>
-            <a:lstStyle/>
-            <a:p>
-              <a:endParaRPr lang="en-GB"/>
-            </a:p>
-          </p:txBody>
-        </p:sp>
-      </p:grpSp>
-      <p:sp>
-        <p:nvSpPr>
-          <p:cNvPr id="19" name="Donut 24">
-            <a:extLst>
-              <a:ext uri="{FF2B5EF4-FFF2-40B4-BE49-F238E27FC236}">
-                <a16:creationId xmlns:a16="http://schemas.microsoft.com/office/drawing/2014/main" id="{9A19DB07-B600-957A-A871-09C79454867A}"/>
-              </a:ext>
-            </a:extLst>
-          </p:cNvPr>
-          <p:cNvSpPr/>
-          <p:nvPr/>
-        </p:nvSpPr>
-        <p:spPr bwMode="gray">
-          <a:xfrm>
-            <a:off x="-3041694" y="33844"/>
-            <a:ext cx="540060" cy="540060"/>
-          </a:xfrm>
-          <a:prstGeom prst="donut">
-            <a:avLst>
-              <a:gd name="adj" fmla="val 7083"/>
-            </a:avLst>
-          </a:prstGeom>
-          <a:solidFill>
-            <a:schemeClr val="accent4"/>
-          </a:solidFill>
-          <a:ln>
-            <a:noFill/>
-          </a:ln>
-        </p:spPr>
-        <p:style>
-          <a:lnRef idx="2">
-            <a:schemeClr val="accent1">
-              <a:shade val="50000"/>
-            </a:schemeClr>
-          </a:lnRef>
-          <a:fillRef idx="1">
-            <a:schemeClr val="accent1"/>
-          </a:fillRef>
-          <a:effectRef idx="0">
-            <a:schemeClr val="accent1"/>
-          </a:effectRef>
-          <a:fontRef idx="minor">
-            <a:schemeClr val="lt1"/>
-          </a:fontRef>
-        </p:style>
-        <p:txBody>
-          <a:bodyPr rtlCol="0" anchor="ctr"/>
-          <a:lstStyle/>
-          <a:p>
-            <a:pPr algn="ctr"/>
-            <a:endParaRPr lang="en-GB">
-              <a:solidFill>
-                <a:schemeClr val="tx1"/>
-              </a:solidFill>
-            </a:endParaRPr>
-          </a:p>
-        </p:txBody>
-      </p:sp>
-      <p:sp>
-        <p:nvSpPr>
-          <p:cNvPr id="20" name="Freeform 5">
-            <a:extLst>
-              <a:ext uri="{FF2B5EF4-FFF2-40B4-BE49-F238E27FC236}">
-                <a16:creationId xmlns:a16="http://schemas.microsoft.com/office/drawing/2014/main" id="{DC09E6E8-9208-DBBB-548D-0AB27E118E80}"/>
-              </a:ext>
-            </a:extLst>
-          </p:cNvPr>
-          <p:cNvSpPr>
-            <a:spLocks noEditPoints="1"/>
-          </p:cNvSpPr>
-          <p:nvPr/>
-        </p:nvSpPr>
-        <p:spPr bwMode="gray">
-          <a:xfrm>
-            <a:off x="-3053321" y="303874"/>
-            <a:ext cx="155642" cy="338230"/>
-          </a:xfrm>
-          <a:custGeom>
-            <a:avLst/>
-            <a:gdLst>
-              <a:gd name="T0" fmla="*/ 469 w 613"/>
-              <a:gd name="T1" fmla="*/ 0 h 1333"/>
-              <a:gd name="T2" fmla="*/ 603 w 613"/>
-              <a:gd name="T3" fmla="*/ 131 h 1333"/>
-              <a:gd name="T4" fmla="*/ 424 w 613"/>
-              <a:gd name="T5" fmla="*/ 298 h 1333"/>
-              <a:gd name="T6" fmla="*/ 293 w 613"/>
-              <a:gd name="T7" fmla="*/ 165 h 1333"/>
-              <a:gd name="T8" fmla="*/ 469 w 613"/>
-              <a:gd name="T9" fmla="*/ 0 h 1333"/>
-              <a:gd name="T10" fmla="*/ 194 w 613"/>
-              <a:gd name="T11" fmla="*/ 1333 h 1333"/>
-              <a:gd name="T12" fmla="*/ 121 w 613"/>
-              <a:gd name="T13" fmla="*/ 1098 h 1333"/>
-              <a:gd name="T14" fmla="*/ 202 w 613"/>
-              <a:gd name="T15" fmla="*/ 759 h 1333"/>
-              <a:gd name="T16" fmla="*/ 202 w 613"/>
-              <a:gd name="T17" fmla="*/ 683 h 1333"/>
-              <a:gd name="T18" fmla="*/ 35 w 613"/>
-              <a:gd name="T19" fmla="*/ 757 h 1333"/>
-              <a:gd name="T20" fmla="*/ 0 w 613"/>
-              <a:gd name="T21" fmla="*/ 699 h 1333"/>
-              <a:gd name="T22" fmla="*/ 453 w 613"/>
-              <a:gd name="T23" fmla="*/ 468 h 1333"/>
-              <a:gd name="T24" fmla="*/ 500 w 613"/>
-              <a:gd name="T25" fmla="*/ 683 h 1333"/>
-              <a:gd name="T26" fmla="*/ 408 w 613"/>
-              <a:gd name="T27" fmla="*/ 1040 h 1333"/>
-              <a:gd name="T28" fmla="*/ 415 w 613"/>
-              <a:gd name="T29" fmla="*/ 1125 h 1333"/>
-              <a:gd name="T30" fmla="*/ 573 w 613"/>
-              <a:gd name="T31" fmla="*/ 1044 h 1333"/>
-              <a:gd name="T32" fmla="*/ 613 w 613"/>
-              <a:gd name="T33" fmla="*/ 1098 h 1333"/>
-              <a:gd name="T34" fmla="*/ 194 w 613"/>
-              <a:gd name="T35" fmla="*/ 1333 h 1333"/>
-            </a:gdLst>
-            <a:ahLst/>
-            <a:cxnLst>
-              <a:cxn ang="0">
-                <a:pos x="T0" y="T1"/>
-              </a:cxn>
-              <a:cxn ang="0">
-                <a:pos x="T2" y="T3"/>
-              </a:cxn>
-              <a:cxn ang="0">
-                <a:pos x="T4" y="T5"/>
-              </a:cxn>
-              <a:cxn ang="0">
-                <a:pos x="T6" y="T7"/>
-              </a:cxn>
-              <a:cxn ang="0">
-                <a:pos x="T8" y="T9"/>
-              </a:cxn>
-              <a:cxn ang="0">
-                <a:pos x="T10" y="T11"/>
-              </a:cxn>
-              <a:cxn ang="0">
-                <a:pos x="T12" y="T13"/>
-              </a:cxn>
-              <a:cxn ang="0">
-                <a:pos x="T14" y="T15"/>
-              </a:cxn>
-              <a:cxn ang="0">
-                <a:pos x="T16" y="T17"/>
-              </a:cxn>
-              <a:cxn ang="0">
-                <a:pos x="T18" y="T19"/>
-              </a:cxn>
-              <a:cxn ang="0">
-                <a:pos x="T20" y="T21"/>
-              </a:cxn>
-              <a:cxn ang="0">
-                <a:pos x="T22" y="T23"/>
-              </a:cxn>
-              <a:cxn ang="0">
-                <a:pos x="T24" y="T25"/>
-              </a:cxn>
-              <a:cxn ang="0">
-                <a:pos x="T26" y="T27"/>
-              </a:cxn>
-              <a:cxn ang="0">
-                <a:pos x="T28" y="T29"/>
-              </a:cxn>
-              <a:cxn ang="0">
-                <a:pos x="T30" y="T31"/>
-              </a:cxn>
-              <a:cxn ang="0">
-                <a:pos x="T32" y="T33"/>
-              </a:cxn>
-              <a:cxn ang="0">
-                <a:pos x="T34" y="T35"/>
-              </a:cxn>
-            </a:cxnLst>
-            <a:rect l="0" t="0" r="r" b="b"/>
-            <a:pathLst>
-              <a:path w="613" h="1333">
-                <a:moveTo>
-                  <a:pt x="469" y="0"/>
-                </a:moveTo>
-                <a:cubicBezTo>
-                  <a:pt x="558" y="0"/>
-                  <a:pt x="603" y="61"/>
-                  <a:pt x="603" y="131"/>
-                </a:cubicBezTo>
-                <a:cubicBezTo>
-                  <a:pt x="603" y="217"/>
-                  <a:pt x="525" y="298"/>
-                  <a:pt x="424" y="298"/>
-                </a:cubicBezTo>
-                <a:cubicBezTo>
-                  <a:pt x="340" y="298"/>
-                  <a:pt x="290" y="248"/>
-                  <a:pt x="293" y="165"/>
-                </a:cubicBezTo>
-                <a:cubicBezTo>
-                  <a:pt x="293" y="96"/>
-                  <a:pt x="351" y="0"/>
-                  <a:pt x="469" y="0"/>
-                </a:cubicBezTo>
-                <a:close/>
-                <a:moveTo>
-                  <a:pt x="194" y="1333"/>
-                </a:moveTo>
-                <a:cubicBezTo>
-                  <a:pt x="123" y="1333"/>
-                  <a:pt x="72" y="1290"/>
-                  <a:pt x="121" y="1098"/>
-                </a:cubicBezTo>
-                <a:lnTo>
-                  <a:pt x="202" y="759"/>
-                </a:lnTo>
-                <a:cubicBezTo>
-                  <a:pt x="216" y="705"/>
-                  <a:pt x="218" y="683"/>
-                  <a:pt x="202" y="683"/>
-                </a:cubicBezTo>
-                <a:cubicBezTo>
-                  <a:pt x="181" y="683"/>
-                  <a:pt x="89" y="721"/>
-                  <a:pt x="35" y="757"/>
-                </a:cubicBezTo>
-                <a:lnTo>
-                  <a:pt x="0" y="699"/>
-                </a:lnTo>
-                <a:cubicBezTo>
-                  <a:pt x="171" y="553"/>
-                  <a:pt x="369" y="468"/>
-                  <a:pt x="453" y="468"/>
-                </a:cubicBezTo>
-                <a:cubicBezTo>
-                  <a:pt x="524" y="468"/>
-                  <a:pt x="536" y="552"/>
-                  <a:pt x="500" y="683"/>
-                </a:cubicBezTo>
-                <a:lnTo>
-                  <a:pt x="408" y="1040"/>
-                </a:lnTo>
-                <a:cubicBezTo>
-                  <a:pt x="391" y="1103"/>
-                  <a:pt x="398" y="1125"/>
-                  <a:pt x="415" y="1125"/>
-                </a:cubicBezTo>
-                <a:cubicBezTo>
-                  <a:pt x="436" y="1125"/>
-                  <a:pt x="505" y="1098"/>
-                  <a:pt x="573" y="1044"/>
-                </a:cubicBezTo>
-                <a:lnTo>
-                  <a:pt x="613" y="1098"/>
-                </a:lnTo>
-                <a:cubicBezTo>
-                  <a:pt x="446" y="1268"/>
-                  <a:pt x="264" y="1333"/>
-                  <a:pt x="194" y="1333"/>
-                </a:cubicBezTo>
-                <a:close/>
-              </a:path>
-            </a:pathLst>
-          </a:custGeom>
-          <a:solidFill>
-            <a:srgbClr val="ED0F69"/>
-          </a:solidFill>
-          <a:ln>
-            <a:noFill/>
-          </a:ln>
-        </p:spPr>
-        <p:txBody>
-          <a:bodyPr vert="horz" wrap="square" lIns="91440" tIns="45720" rIns="91440" bIns="45720" numCol="1" anchor="t" anchorCtr="0" compatLnSpc="1">
-            <a:prstTxWarp prst="textNoShape">
-              <a:avLst/>
-            </a:prstTxWarp>
-          </a:bodyPr>
-          <a:lstStyle/>
-          <a:p>
-            <a:endParaRPr lang="en-GB"/>
+            <a:endParaRPr lang="en-AU"/>
           </a:p>
         </p:txBody>
       </p:sp>
     </p:spTree>
     <p:extLst>
       <p:ext uri="{BB962C8B-B14F-4D97-AF65-F5344CB8AC3E}">
-        <p14:creationId xmlns:p14="http://schemas.microsoft.com/office/powerpoint/2010/main" val="2524559585"/>
+        <p14:creationId xmlns:p14="http://schemas.microsoft.com/office/powerpoint/2010/main" val="1114737724"/>
       </p:ext>
     </p:extLst>
   </p:cSld>
@@ -24494,6 +23641,1316 @@
       </p:transition>
     </mc:Fallback>
   </mc:AlternateContent>
+</p:sld>
+</file>
+
+<file path=ppt/slides/slide10.xml><?xml version="1.0" encoding="utf-8"?>
+<p:sld xmlns:a="http://schemas.openxmlformats.org/drawingml/2006/main" xmlns:r="http://schemas.openxmlformats.org/officeDocument/2006/relationships" xmlns:p="http://schemas.openxmlformats.org/presentationml/2006/main">
+  <p:cSld>
+    <p:spTree>
+      <p:nvGrpSpPr>
+        <p:cNvPr id="1" name=""/>
+        <p:cNvGrpSpPr/>
+        <p:nvPr/>
+      </p:nvGrpSpPr>
+      <p:grpSpPr>
+        <a:xfrm>
+          <a:off x="0" y="0"/>
+          <a:ext cx="0" cy="0"/>
+          <a:chOff x="0" y="0"/>
+          <a:chExt cx="0" cy="0"/>
+        </a:xfrm>
+      </p:grpSpPr>
+      <p:sp>
+        <p:nvSpPr>
+          <p:cNvPr id="2" name="Title 1">
+            <a:extLst>
+              <a:ext uri="{FF2B5EF4-FFF2-40B4-BE49-F238E27FC236}">
+                <a16:creationId xmlns:a16="http://schemas.microsoft.com/office/drawing/2014/main" id="{D73378B2-2EBE-BDD8-0E6A-8AA3EF3EE2DC}"/>
+              </a:ext>
+            </a:extLst>
+          </p:cNvPr>
+          <p:cNvSpPr>
+            <a:spLocks noGrp="1"/>
+          </p:cNvSpPr>
+          <p:nvPr>
+            <p:ph type="title"/>
+          </p:nvPr>
+        </p:nvSpPr>
+        <p:spPr/>
+        <p:txBody>
+          <a:bodyPr/>
+          <a:lstStyle/>
+          <a:p>
+            <a:r>
+              <a:rPr lang="en-AU" dirty="0"/>
+              <a:t>Progress</a:t>
+            </a:r>
+          </a:p>
+        </p:txBody>
+      </p:sp>
+      <p:sp>
+        <p:nvSpPr>
+          <p:cNvPr id="3" name="Text Placeholder 2">
+            <a:extLst>
+              <a:ext uri="{FF2B5EF4-FFF2-40B4-BE49-F238E27FC236}">
+                <a16:creationId xmlns:a16="http://schemas.microsoft.com/office/drawing/2014/main" id="{5C68A61C-E458-0EB7-5DDE-D9E18E3421E0}"/>
+              </a:ext>
+            </a:extLst>
+          </p:cNvPr>
+          <p:cNvSpPr>
+            <a:spLocks noGrp="1"/>
+          </p:cNvSpPr>
+          <p:nvPr>
+            <p:ph type="body" sz="quarter" idx="11"/>
+          </p:nvPr>
+        </p:nvSpPr>
+        <p:spPr/>
+        <p:txBody>
+          <a:bodyPr/>
+          <a:lstStyle/>
+          <a:p>
+            <a:r>
+              <a:rPr lang="en-AU" dirty="0"/>
+              <a:t>02</a:t>
+            </a:r>
+          </a:p>
+        </p:txBody>
+      </p:sp>
+      <p:sp>
+        <p:nvSpPr>
+          <p:cNvPr id="5" name="Footer Placeholder 4">
+            <a:extLst>
+              <a:ext uri="{FF2B5EF4-FFF2-40B4-BE49-F238E27FC236}">
+                <a16:creationId xmlns:a16="http://schemas.microsoft.com/office/drawing/2014/main" id="{C9432DFB-1584-AD15-E91D-3C8A99B1EC2C}"/>
+              </a:ext>
+            </a:extLst>
+          </p:cNvPr>
+          <p:cNvSpPr>
+            <a:spLocks noGrp="1"/>
+          </p:cNvSpPr>
+          <p:nvPr>
+            <p:ph type="ftr" sz="quarter" idx="10"/>
+          </p:nvPr>
+        </p:nvSpPr>
+        <p:spPr/>
+        <p:txBody>
+          <a:bodyPr/>
+          <a:lstStyle/>
+          <a:p>
+            <a:endParaRPr lang="en-AU" dirty="0"/>
+          </a:p>
+        </p:txBody>
+      </p:sp>
+      <p:sp>
+        <p:nvSpPr>
+          <p:cNvPr id="6" name="Slide Number Placeholder 5">
+            <a:extLst>
+              <a:ext uri="{FF2B5EF4-FFF2-40B4-BE49-F238E27FC236}">
+                <a16:creationId xmlns:a16="http://schemas.microsoft.com/office/drawing/2014/main" id="{4E49DAD8-968B-9C3A-9429-2F55625CB1E3}"/>
+              </a:ext>
+            </a:extLst>
+          </p:cNvPr>
+          <p:cNvSpPr>
+            <a:spLocks noGrp="1"/>
+          </p:cNvSpPr>
+          <p:nvPr>
+            <p:ph type="sldNum" sz="quarter" idx="14"/>
+          </p:nvPr>
+        </p:nvSpPr>
+        <p:spPr/>
+        <p:txBody>
+          <a:bodyPr/>
+          <a:lstStyle/>
+          <a:p>
+            <a:fld id="{E917DE0E-AFB1-41FD-BC35-27DB61CA125F}" type="slidenum">
+              <a:rPr lang="en-AU" smtClean="0"/>
+              <a:pPr/>
+              <a:t>10</a:t>
+            </a:fld>
+            <a:endParaRPr lang="en-AU" dirty="0"/>
+          </a:p>
+        </p:txBody>
+      </p:sp>
+    </p:spTree>
+    <p:extLst>
+      <p:ext uri="{BB962C8B-B14F-4D97-AF65-F5344CB8AC3E}">
+        <p14:creationId xmlns:p14="http://schemas.microsoft.com/office/powerpoint/2010/main" val="1197911869"/>
+      </p:ext>
+    </p:extLst>
+  </p:cSld>
+  <p:clrMapOvr>
+    <a:masterClrMapping/>
+  </p:clrMapOvr>
+  <mc:AlternateContent xmlns:mc="http://schemas.openxmlformats.org/markup-compatibility/2006" xmlns:p14="http://schemas.microsoft.com/office/powerpoint/2010/main">
+    <mc:Choice Requires="p14">
+      <p:transition spd="med" p14:dur="700">
+        <p:fade/>
+      </p:transition>
+    </mc:Choice>
+    <mc:Fallback xmlns="">
+      <p:transition spd="med">
+        <p:fade/>
+      </p:transition>
+    </mc:Fallback>
+  </mc:AlternateContent>
+</p:sld>
+</file>
+
+<file path=ppt/slides/slide11.xml><?xml version="1.0" encoding="utf-8"?>
+<p:sld xmlns:a="http://schemas.openxmlformats.org/drawingml/2006/main" xmlns:r="http://schemas.openxmlformats.org/officeDocument/2006/relationships" xmlns:p="http://schemas.openxmlformats.org/presentationml/2006/main">
+  <p:cSld>
+    <p:spTree>
+      <p:nvGrpSpPr>
+        <p:cNvPr id="1" name=""/>
+        <p:cNvGrpSpPr/>
+        <p:nvPr/>
+      </p:nvGrpSpPr>
+      <p:grpSpPr>
+        <a:xfrm>
+          <a:off x="0" y="0"/>
+          <a:ext cx="0" cy="0"/>
+          <a:chOff x="0" y="0"/>
+          <a:chExt cx="0" cy="0"/>
+        </a:xfrm>
+      </p:grpSpPr>
+      <p:sp>
+        <p:nvSpPr>
+          <p:cNvPr id="2" name="Title 1"/>
+          <p:cNvSpPr>
+            <a:spLocks noGrp="1"/>
+          </p:cNvSpPr>
+          <p:nvPr>
+            <p:ph type="title"/>
+          </p:nvPr>
+        </p:nvSpPr>
+        <p:spPr/>
+        <p:txBody>
+          <a:bodyPr/>
+          <a:lstStyle/>
+          <a:p>
+            <a:r>
+              <a:rPr lang="en-AU" dirty="0"/>
+              <a:t>Progress: Datasets &amp; Sampling</a:t>
+            </a:r>
+          </a:p>
+        </p:txBody>
+      </p:sp>
+      <p:sp>
+        <p:nvSpPr>
+          <p:cNvPr id="4" name="Left Caption"/>
+          <p:cNvSpPr>
+            <a:spLocks noGrp="1"/>
+          </p:cNvSpPr>
+          <p:nvPr>
+            <p:ph sz="quarter" idx="32"/>
+          </p:nvPr>
+        </p:nvSpPr>
+        <p:spPr/>
+        <p:txBody>
+          <a:bodyPr/>
+          <a:lstStyle/>
+          <a:p>
+            <a:r>
+              <a:rPr lang="en-AU" sz="1400" dirty="0"/>
+              <a:t>Comprehensive: 13.4k images / 24 classes (capped 500/class)</a:t>
+            </a:r>
+          </a:p>
+        </p:txBody>
+      </p:sp>
+      <p:pic>
+        <p:nvPicPr>
+          <p:cNvPr id="5" name="Comprehensive Chart"/>
+          <p:cNvPicPr>
+            <a:picLocks noChangeAspect="1"/>
+          </p:cNvPicPr>
+          <p:nvPr/>
+        </p:nvPicPr>
+        <p:blipFill>
+          <a:blip r:embed="rId2"/>
+          <a:stretch>
+            <a:fillRect/>
+          </a:stretch>
+        </p:blipFill>
+        <p:spPr>
+          <a:xfrm>
+            <a:off x="479424" y="2703338"/>
+            <a:ext cx="5312503" cy="3164620"/>
+          </a:xfrm>
+          <a:prstGeom prst="rect">
+            <a:avLst/>
+          </a:prstGeom>
+        </p:spPr>
+      </p:pic>
+      <p:sp>
+        <p:nvSpPr>
+          <p:cNvPr id="6" name="Right Caption"/>
+          <p:cNvSpPr>
+            <a:spLocks noGrp="1"/>
+          </p:cNvSpPr>
+          <p:nvPr>
+            <p:ph sz="quarter" idx="34"/>
+          </p:nvPr>
+        </p:nvSpPr>
+        <p:spPr/>
+        <p:txBody>
+          <a:bodyPr/>
+          <a:lstStyle/>
+          <a:p>
+            <a:r>
+              <a:rPr lang="en-AU" sz="1400" dirty="0"/>
+              <a:t>Balanced: 263k images / 35 classes (sampled to 17.5k)</a:t>
+            </a:r>
+          </a:p>
+        </p:txBody>
+      </p:sp>
+      <p:pic>
+        <p:nvPicPr>
+          <p:cNvPr id="7" name="Balanced Chart"/>
+          <p:cNvPicPr>
+            <a:picLocks noChangeAspect="1"/>
+          </p:cNvPicPr>
+          <p:nvPr/>
+        </p:nvPicPr>
+        <p:blipFill>
+          <a:blip r:embed="rId3"/>
+          <a:stretch>
+            <a:fillRect/>
+          </a:stretch>
+        </p:blipFill>
+        <p:spPr>
+          <a:xfrm>
+            <a:off x="6386677" y="2703338"/>
+            <a:ext cx="5312503" cy="3678412"/>
+          </a:xfrm>
+          <a:prstGeom prst="rect">
+            <a:avLst/>
+          </a:prstGeom>
+        </p:spPr>
+      </p:pic>
+      <p:sp>
+        <p:nvSpPr>
+          <p:cNvPr id="9" name="Text Placeholder 8">
+            <a:extLst>
+              <a:ext uri="{FF2B5EF4-FFF2-40B4-BE49-F238E27FC236}">
+                <a16:creationId xmlns:a16="http://schemas.microsoft.com/office/drawing/2014/main" id="{6D8DA5FF-C5E8-373D-C80C-0FF87D08FD20}"/>
+              </a:ext>
+            </a:extLst>
+          </p:cNvPr>
+          <p:cNvSpPr>
+            <a:spLocks noGrp="1"/>
+          </p:cNvSpPr>
+          <p:nvPr>
+            <p:ph type="body" sz="quarter" idx="31"/>
+          </p:nvPr>
+        </p:nvSpPr>
+        <p:spPr/>
+        <p:txBody>
+          <a:bodyPr/>
+          <a:lstStyle/>
+          <a:p>
+            <a:endParaRPr lang="en-AU"/>
+          </a:p>
+        </p:txBody>
+      </p:sp>
+    </p:spTree>
+  </p:cSld>
+  <p:clrMapOvr>
+    <a:masterClrMapping/>
+  </p:clrMapOvr>
+</p:sld>
+</file>
+
+<file path=ppt/slides/slide12.xml><?xml version="1.0" encoding="utf-8"?>
+<p:sld xmlns:a="http://schemas.openxmlformats.org/drawingml/2006/main" xmlns:r="http://schemas.openxmlformats.org/officeDocument/2006/relationships" xmlns:p="http://schemas.openxmlformats.org/presentationml/2006/main">
+  <p:cSld>
+    <p:spTree>
+      <p:nvGrpSpPr>
+        <p:cNvPr id="1" name=""/>
+        <p:cNvGrpSpPr/>
+        <p:nvPr/>
+      </p:nvGrpSpPr>
+      <p:grpSpPr>
+        <a:xfrm>
+          <a:off x="0" y="0"/>
+          <a:ext cx="0" cy="0"/>
+          <a:chOff x="0" y="0"/>
+          <a:chExt cx="0" cy="0"/>
+        </a:xfrm>
+      </p:grpSpPr>
+      <p:sp>
+        <p:nvSpPr>
+          <p:cNvPr id="2" name="Title 1"/>
+          <p:cNvSpPr>
+            <a:spLocks noGrp="1"/>
+          </p:cNvSpPr>
+          <p:nvPr>
+            <p:ph type="title"/>
+          </p:nvPr>
+        </p:nvSpPr>
+        <p:spPr/>
+        <p:txBody>
+          <a:bodyPr/>
+          <a:lstStyle/>
+          <a:p>
+            <a:pPr>
+              <a:buNone/>
+            </a:pPr>
+            <a:r>
+              <a:rPr lang="en-AU" dirty="0"/>
+              <a:t>Progress: Centralised Baseline</a:t>
+            </a:r>
+          </a:p>
+        </p:txBody>
+      </p:sp>
+      <p:sp>
+        <p:nvSpPr>
+          <p:cNvPr id="3" name="Subtitle"/>
+          <p:cNvSpPr>
+            <a:spLocks noGrp="1"/>
+          </p:cNvSpPr>
+          <p:nvPr>
+            <p:ph type="body" sz="quarter" idx="34"/>
+          </p:nvPr>
+        </p:nvSpPr>
+        <p:spPr/>
+        <p:txBody>
+          <a:bodyPr/>
+          <a:lstStyle/>
+          <a:p>
+            <a:pPr>
+              <a:buNone/>
+            </a:pPr>
+            <a:r>
+              <a:rPr lang="en-AU" dirty="0"/>
+              <a:t>Working pipeline; first baseline trained on the balanced sample</a:t>
+            </a:r>
+          </a:p>
+        </p:txBody>
+      </p:sp>
+      <p:sp>
+        <p:nvSpPr>
+          <p:cNvPr id="4" name="Setup Pullout"/>
+          <p:cNvSpPr>
+            <a:spLocks noGrp="1"/>
+          </p:cNvSpPr>
+          <p:nvPr>
+            <p:ph type="body" sz="quarter" idx="19"/>
+          </p:nvPr>
+        </p:nvSpPr>
+        <p:spPr/>
+        <p:txBody>
+          <a:bodyPr/>
+          <a:lstStyle/>
+          <a:p>
+            <a:pPr>
+              <a:buNone/>
+            </a:pPr>
+            <a:r>
+              <a:rPr lang="en-AU" sz="1800" b="1" dirty="0"/>
+              <a:t>SETUP</a:t>
+            </a:r>
+          </a:p>
+          <a:p>
+            <a:pPr>
+              <a:buNone/>
+            </a:pPr>
+            <a:endParaRPr lang="en-AU" dirty="0"/>
+          </a:p>
+          <a:p>
+            <a:pPr>
+              <a:buNone/>
+            </a:pPr>
+            <a:r>
+              <a:rPr lang="en-AU" dirty="0"/>
+              <a:t>ResNet on the balanced sample</a:t>
+            </a:r>
+          </a:p>
+          <a:p>
+            <a:pPr>
+              <a:buNone/>
+            </a:pPr>
+            <a:endParaRPr lang="en-AU" dirty="0"/>
+          </a:p>
+          <a:p>
+            <a:pPr>
+              <a:buNone/>
+            </a:pPr>
+            <a:r>
+              <a:rPr lang="en-AU" dirty="0"/>
+              <a:t>17,500 images / 35 classes</a:t>
+            </a:r>
+          </a:p>
+          <a:p>
+            <a:pPr>
+              <a:buNone/>
+            </a:pPr>
+            <a:r>
+              <a:rPr lang="en-AU" dirty="0"/>
+              <a:t>10 epochs</a:t>
+            </a:r>
+          </a:p>
+        </p:txBody>
+      </p:sp>
+      <p:sp>
+        <p:nvSpPr>
+          <p:cNvPr id="5" name="Results Pullout"/>
+          <p:cNvSpPr>
+            <a:spLocks noGrp="1"/>
+          </p:cNvSpPr>
+          <p:nvPr>
+            <p:ph type="body" sz="quarter" idx="20"/>
+          </p:nvPr>
+        </p:nvSpPr>
+        <p:spPr/>
+        <p:txBody>
+          <a:bodyPr/>
+          <a:lstStyle/>
+          <a:p>
+            <a:pPr>
+              <a:buNone/>
+            </a:pPr>
+            <a:r>
+              <a:rPr lang="en-AU" sz="1800" b="1" dirty="0"/>
+              <a:t>TEST RESULTS</a:t>
+            </a:r>
+          </a:p>
+          <a:p>
+            <a:pPr>
+              <a:buNone/>
+            </a:pPr>
+            <a:endParaRPr lang="en-AU" dirty="0"/>
+          </a:p>
+          <a:p>
+            <a:pPr>
+              <a:buNone/>
+            </a:pPr>
+            <a:r>
+              <a:rPr lang="en-AU" sz="4400" b="1" dirty="0"/>
+              <a:t>57.6%</a:t>
+            </a:r>
+          </a:p>
+          <a:p>
+            <a:pPr>
+              <a:buNone/>
+            </a:pPr>
+            <a:r>
+              <a:rPr lang="en-AU" dirty="0"/>
+              <a:t>Top-1 accuracy</a:t>
+            </a:r>
+          </a:p>
+          <a:p>
+            <a:pPr>
+              <a:buNone/>
+            </a:pPr>
+            <a:endParaRPr lang="en-AU" dirty="0"/>
+          </a:p>
+          <a:p>
+            <a:pPr>
+              <a:buNone/>
+            </a:pPr>
+            <a:r>
+              <a:rPr lang="en-AU" dirty="0"/>
+              <a:t>Macro F1: 0.569</a:t>
+            </a:r>
+          </a:p>
+          <a:p>
+            <a:pPr>
+              <a:buNone/>
+            </a:pPr>
+            <a:r>
+              <a:rPr lang="en-AU" dirty="0"/>
+              <a:t>Test loss: 1.44</a:t>
+            </a:r>
+          </a:p>
+        </p:txBody>
+      </p:sp>
+      <p:sp>
+        <p:nvSpPr>
+          <p:cNvPr id="6" name="Context Pullout"/>
+          <p:cNvSpPr>
+            <a:spLocks noGrp="1"/>
+          </p:cNvSpPr>
+          <p:nvPr>
+            <p:ph type="body" sz="quarter" idx="21"/>
+          </p:nvPr>
+        </p:nvSpPr>
+        <p:spPr/>
+        <p:txBody>
+          <a:bodyPr/>
+          <a:lstStyle/>
+          <a:p>
+            <a:pPr>
+              <a:buNone/>
+            </a:pPr>
+            <a:r>
+              <a:rPr lang="en-AU" sz="1800" b="1" dirty="0"/>
+              <a:t>CONTEXT</a:t>
+            </a:r>
+          </a:p>
+          <a:p>
+            <a:pPr>
+              <a:buNone/>
+            </a:pPr>
+            <a:endParaRPr lang="en-AU" dirty="0"/>
+          </a:p>
+          <a:p>
+            <a:pPr>
+              <a:buNone/>
+            </a:pPr>
+            <a:r>
+              <a:rPr lang="en-AU" dirty="0"/>
+              <a:t>~20× random (1/35 = 2.9%)</a:t>
+            </a:r>
+          </a:p>
+          <a:p>
+            <a:pPr>
+              <a:buNone/>
+            </a:pPr>
+            <a:endParaRPr lang="en-AU" dirty="0"/>
+          </a:p>
+          <a:p>
+            <a:pPr>
+              <a:buNone/>
+            </a:pPr>
+            <a:r>
+              <a:rPr lang="en-AU" dirty="0"/>
+              <a:t>In line with literature for 30+ class fine-grained skin tasks (50–65%)</a:t>
+            </a:r>
+          </a:p>
+          <a:p>
+            <a:pPr>
+              <a:buNone/>
+            </a:pPr>
+            <a:endParaRPr lang="en-AU" dirty="0"/>
+          </a:p>
+          <a:p>
+            <a:pPr>
+              <a:buNone/>
+            </a:pPr>
+            <a:r>
+              <a:rPr lang="en-AU" b="1" dirty="0"/>
+              <a:t>Next: Dirichlet sampling, </a:t>
+            </a:r>
+            <a:r>
+              <a:rPr lang="en-AU" b="1" dirty="0" err="1"/>
+              <a:t>FedAvg</a:t>
+            </a:r>
+            <a:endParaRPr lang="en-AU" b="1" dirty="0"/>
+          </a:p>
+        </p:txBody>
+      </p:sp>
+    </p:spTree>
+  </p:cSld>
+  <p:clrMapOvr>
+    <a:masterClrMapping/>
+  </p:clrMapOvr>
+</p:sld>
+</file>
+
+<file path=ppt/slides/slide13.xml><?xml version="1.0" encoding="utf-8"?>
+<p:sld xmlns:a="http://schemas.openxmlformats.org/drawingml/2006/main" xmlns:r="http://schemas.openxmlformats.org/officeDocument/2006/relationships" xmlns:p="http://schemas.openxmlformats.org/presentationml/2006/main">
+  <p:cSld>
+    <p:spTree>
+      <p:nvGrpSpPr>
+        <p:cNvPr id="1" name=""/>
+        <p:cNvGrpSpPr/>
+        <p:nvPr/>
+      </p:nvGrpSpPr>
+      <p:grpSpPr>
+        <a:xfrm>
+          <a:off x="0" y="0"/>
+          <a:ext cx="0" cy="0"/>
+          <a:chOff x="0" y="0"/>
+          <a:chExt cx="0" cy="0"/>
+        </a:xfrm>
+      </p:grpSpPr>
+      <p:sp>
+        <p:nvSpPr>
+          <p:cNvPr id="2" name="Title"/>
+          <p:cNvSpPr>
+            <a:spLocks noGrp="1"/>
+          </p:cNvSpPr>
+          <p:nvPr>
+            <p:ph type="title"/>
+          </p:nvPr>
+        </p:nvSpPr>
+        <p:spPr/>
+        <p:txBody>
+          <a:bodyPr/>
+          <a:lstStyle/>
+          <a:p>
+            <a:r>
+              <a:rPr lang="en-AU" dirty="0"/>
+              <a:t>Progress: Dirichlet Sampling</a:t>
+            </a:r>
+          </a:p>
+        </p:txBody>
+      </p:sp>
+      <p:sp>
+        <p:nvSpPr>
+          <p:cNvPr id="11" name="Caption 1"/>
+          <p:cNvSpPr txBox="1"/>
+          <p:nvPr/>
+        </p:nvSpPr>
+        <p:spPr>
+          <a:xfrm>
+            <a:off x="8617958" y="1621879"/>
+            <a:ext cx="3083720" cy="1450000"/>
+          </a:xfrm>
+          <a:prstGeom prst="rect">
+            <a:avLst/>
+          </a:prstGeom>
+          <a:noFill/>
+        </p:spPr>
+        <p:txBody>
+          <a:bodyPr wrap="square" anchor="ctr"/>
+          <a:lstStyle/>
+          <a:p>
+            <a:pPr>
+              <a:buNone/>
+            </a:pPr>
+            <a:r>
+              <a:rPr lang="en-AU" sz="2000" b="1" dirty="0">
+                <a:solidFill>
+                  <a:srgbClr val="4B2D7F"/>
+                </a:solidFill>
+              </a:rPr>
+              <a:t>α = 0.1 — extreme skew</a:t>
+            </a:r>
+          </a:p>
+          <a:p>
+            <a:pPr>
+              <a:buNone/>
+            </a:pPr>
+            <a:r>
+              <a:rPr lang="en-AU" sz="1400" dirty="0"/>
+              <a:t>122 / 280 cells empty; smallest client 334 </a:t>
+            </a:r>
+            <a:r>
+              <a:rPr lang="en-AU" sz="1400" dirty="0" err="1"/>
+              <a:t>imgs</a:t>
+            </a:r>
+            <a:endParaRPr lang="en-AU" sz="1400" dirty="0"/>
+          </a:p>
+        </p:txBody>
+      </p:sp>
+      <p:sp>
+        <p:nvSpPr>
+          <p:cNvPr id="13" name="Caption 2"/>
+          <p:cNvSpPr txBox="1"/>
+          <p:nvPr/>
+        </p:nvSpPr>
+        <p:spPr>
+          <a:xfrm>
+            <a:off x="8646411" y="2924944"/>
+            <a:ext cx="3083720" cy="1450000"/>
+          </a:xfrm>
+          <a:prstGeom prst="rect">
+            <a:avLst/>
+          </a:prstGeom>
+          <a:noFill/>
+        </p:spPr>
+        <p:txBody>
+          <a:bodyPr wrap="square" anchor="ctr"/>
+          <a:lstStyle/>
+          <a:p>
+            <a:pPr>
+              <a:buNone/>
+            </a:pPr>
+            <a:r>
+              <a:rPr lang="en-AU" sz="2000" b="1" dirty="0">
+                <a:solidFill>
+                  <a:srgbClr val="4B2D7F"/>
+                </a:solidFill>
+              </a:rPr>
+              <a:t>α = 0.5 — realistic skew</a:t>
+            </a:r>
+          </a:p>
+          <a:p>
+            <a:pPr>
+              <a:buNone/>
+            </a:pPr>
+            <a:r>
+              <a:rPr lang="en-AU" sz="1400" dirty="0"/>
+              <a:t>12 / 280 cells empty; smallest client 1,678 </a:t>
+            </a:r>
+            <a:r>
+              <a:rPr lang="en-AU" sz="1400" dirty="0" err="1"/>
+              <a:t>imgs</a:t>
+            </a:r>
+            <a:endParaRPr lang="en-AU" sz="1400" dirty="0"/>
+          </a:p>
+        </p:txBody>
+      </p:sp>
+      <p:sp>
+        <p:nvSpPr>
+          <p:cNvPr id="15" name="Caption 3"/>
+          <p:cNvSpPr txBox="1"/>
+          <p:nvPr/>
+        </p:nvSpPr>
+        <p:spPr>
+          <a:xfrm>
+            <a:off x="8676542" y="4395767"/>
+            <a:ext cx="3053589" cy="1450000"/>
+          </a:xfrm>
+          <a:prstGeom prst="rect">
+            <a:avLst/>
+          </a:prstGeom>
+          <a:noFill/>
+        </p:spPr>
+        <p:txBody>
+          <a:bodyPr wrap="square" anchor="ctr"/>
+          <a:lstStyle/>
+          <a:p>
+            <a:pPr>
+              <a:buNone/>
+            </a:pPr>
+            <a:r>
+              <a:rPr lang="en-AU" sz="2000" b="1" dirty="0">
+                <a:solidFill>
+                  <a:srgbClr val="4B2D7F"/>
+                </a:solidFill>
+              </a:rPr>
+              <a:t>α = 1.0 — near-IID</a:t>
+            </a:r>
+          </a:p>
+          <a:p>
+            <a:pPr>
+              <a:buNone/>
+            </a:pPr>
+            <a:r>
+              <a:rPr lang="en-AU" sz="1400" dirty="0"/>
+              <a:t>4 / 280 cells empty; smallest client 1,645 </a:t>
+            </a:r>
+            <a:r>
+              <a:rPr lang="en-AU" sz="1400" dirty="0" err="1"/>
+              <a:t>imgs</a:t>
+            </a:r>
+            <a:endParaRPr lang="en-AU" sz="1400" dirty="0"/>
+          </a:p>
+        </p:txBody>
+      </p:sp>
+      <p:pic>
+        <p:nvPicPr>
+          <p:cNvPr id="6" name="Picture 5" descr="The image is a bar chart showing the frequency of various skin conditions, with some having zero occurrences.&#10;&#10;AI-generated content may be incorrect.">
+            <a:extLst>
+              <a:ext uri="{FF2B5EF4-FFF2-40B4-BE49-F238E27FC236}">
+                <a16:creationId xmlns:a16="http://schemas.microsoft.com/office/drawing/2014/main" id="{622F4EFB-71FC-044B-A985-81CBE256E6EB}"/>
+              </a:ext>
+            </a:extLst>
+          </p:cNvPr>
+          <p:cNvPicPr>
+            <a:picLocks noChangeAspect="1"/>
+          </p:cNvPicPr>
+          <p:nvPr/>
+        </p:nvPicPr>
+        <p:blipFill>
+          <a:blip r:embed="rId2"/>
+          <a:stretch>
+            <a:fillRect/>
+          </a:stretch>
+        </p:blipFill>
+        <p:spPr>
+          <a:xfrm>
+            <a:off x="0" y="1484784"/>
+            <a:ext cx="8512892" cy="5015216"/>
+          </a:xfrm>
+          <a:prstGeom prst="rect">
+            <a:avLst/>
+          </a:prstGeom>
+        </p:spPr>
+      </p:pic>
+    </p:spTree>
+  </p:cSld>
+  <p:clrMapOvr>
+    <a:masterClrMapping/>
+  </p:clrMapOvr>
+</p:sld>
+</file>
+
+<file path=ppt/slides/slide14.xml><?xml version="1.0" encoding="utf-8"?>
+<p:sld xmlns:a="http://schemas.openxmlformats.org/drawingml/2006/main" xmlns:r="http://schemas.openxmlformats.org/officeDocument/2006/relationships" xmlns:p="http://schemas.openxmlformats.org/presentationml/2006/main">
+  <p:cSld>
+    <p:spTree>
+      <p:nvGrpSpPr>
+        <p:cNvPr id="1" name=""/>
+        <p:cNvGrpSpPr/>
+        <p:nvPr/>
+      </p:nvGrpSpPr>
+      <p:grpSpPr>
+        <a:xfrm>
+          <a:off x="0" y="0"/>
+          <a:ext cx="0" cy="0"/>
+          <a:chOff x="0" y="0"/>
+          <a:chExt cx="0" cy="0"/>
+        </a:xfrm>
+      </p:grpSpPr>
+      <p:sp>
+        <p:nvSpPr>
+          <p:cNvPr id="2" name="Title"/>
+          <p:cNvSpPr>
+            <a:spLocks noGrp="1"/>
+          </p:cNvSpPr>
+          <p:nvPr>
+            <p:ph type="title"/>
+          </p:nvPr>
+        </p:nvSpPr>
+        <p:spPr/>
+        <p:txBody>
+          <a:bodyPr/>
+          <a:lstStyle/>
+          <a:p>
+            <a:r>
+              <a:rPr lang="en-AU" dirty="0"/>
+              <a:t>Next Steps</a:t>
+            </a:r>
+          </a:p>
+        </p:txBody>
+      </p:sp>
+      <p:sp>
+        <p:nvSpPr>
+          <p:cNvPr id="10" name="N1"/>
+          <p:cNvSpPr>
+            <a:spLocks noGrp="1"/>
+          </p:cNvSpPr>
+          <p:nvPr>
+            <p:ph type="body" sz="quarter" idx="29"/>
+          </p:nvPr>
+        </p:nvSpPr>
+        <p:spPr/>
+        <p:txBody>
+          <a:bodyPr/>
+          <a:lstStyle/>
+          <a:p>
+            <a:r>
+              <a:rPr lang="en-AU" dirty="0"/>
+              <a:t>01</a:t>
+            </a:r>
+          </a:p>
+        </p:txBody>
+      </p:sp>
+      <p:sp>
+        <p:nvSpPr>
+          <p:cNvPr id="11" name="N1H"/>
+          <p:cNvSpPr>
+            <a:spLocks noGrp="1"/>
+          </p:cNvSpPr>
+          <p:nvPr>
+            <p:ph type="body" sz="quarter" idx="19"/>
+          </p:nvPr>
+        </p:nvSpPr>
+        <p:spPr/>
+        <p:txBody>
+          <a:bodyPr/>
+          <a:lstStyle/>
+          <a:p>
+            <a:r>
+              <a:rPr lang="en-AU" dirty="0"/>
+              <a:t>Baseline</a:t>
+            </a:r>
+          </a:p>
+        </p:txBody>
+      </p:sp>
+      <p:sp>
+        <p:nvSpPr>
+          <p:cNvPr id="12" name="N1B"/>
+          <p:cNvSpPr>
+            <a:spLocks noGrp="1"/>
+          </p:cNvSpPr>
+          <p:nvPr>
+            <p:ph type="body" sz="quarter" idx="20"/>
+          </p:nvPr>
+        </p:nvSpPr>
+        <p:spPr/>
+        <p:txBody>
+          <a:bodyPr/>
+          <a:lstStyle/>
+          <a:p>
+            <a:r>
+              <a:rPr lang="en-AU" dirty="0"/>
+              <a:t>Re-run on full datasets, longer training; locks the upper bound for FL comparisons</a:t>
+            </a:r>
+          </a:p>
+        </p:txBody>
+      </p:sp>
+      <p:sp>
+        <p:nvSpPr>
+          <p:cNvPr id="20" name="N2"/>
+          <p:cNvSpPr>
+            <a:spLocks noGrp="1"/>
+          </p:cNvSpPr>
+          <p:nvPr>
+            <p:ph type="body" sz="quarter" idx="30"/>
+          </p:nvPr>
+        </p:nvSpPr>
+        <p:spPr/>
+        <p:txBody>
+          <a:bodyPr/>
+          <a:lstStyle/>
+          <a:p>
+            <a:r>
+              <a:rPr lang="en-AU" dirty="0"/>
+              <a:t>02</a:t>
+            </a:r>
+          </a:p>
+        </p:txBody>
+      </p:sp>
+      <p:sp>
+        <p:nvSpPr>
+          <p:cNvPr id="21" name="N2H"/>
+          <p:cNvSpPr>
+            <a:spLocks noGrp="1"/>
+          </p:cNvSpPr>
+          <p:nvPr>
+            <p:ph type="body" sz="quarter" idx="31"/>
+          </p:nvPr>
+        </p:nvSpPr>
+        <p:spPr/>
+        <p:txBody>
+          <a:bodyPr/>
+          <a:lstStyle/>
+          <a:p>
+            <a:r>
+              <a:rPr lang="en-AU" dirty="0"/>
+              <a:t>FedAvg</a:t>
+            </a:r>
+          </a:p>
+        </p:txBody>
+      </p:sp>
+      <p:sp>
+        <p:nvSpPr>
+          <p:cNvPr id="22" name="N2B"/>
+          <p:cNvSpPr>
+            <a:spLocks noGrp="1"/>
+          </p:cNvSpPr>
+          <p:nvPr>
+            <p:ph type="body" sz="quarter" idx="32"/>
+          </p:nvPr>
+        </p:nvSpPr>
+        <p:spPr/>
+        <p:txBody>
+          <a:bodyPr/>
+          <a:lstStyle/>
+          <a:p>
+            <a:r>
+              <a:rPr lang="en-AU" dirty="0"/>
+              <a:t>Local SGD + weighted parameter aggregation across 8 simulated clients; first run at α = 1.0</a:t>
+            </a:r>
+          </a:p>
+        </p:txBody>
+      </p:sp>
+      <p:sp>
+        <p:nvSpPr>
+          <p:cNvPr id="30" name="N3"/>
+          <p:cNvSpPr>
+            <a:spLocks noGrp="1"/>
+          </p:cNvSpPr>
+          <p:nvPr>
+            <p:ph type="body" sz="quarter" idx="33"/>
+          </p:nvPr>
+        </p:nvSpPr>
+        <p:spPr/>
+        <p:txBody>
+          <a:bodyPr/>
+          <a:lstStyle/>
+          <a:p>
+            <a:r>
+              <a:rPr lang="en-AU" dirty="0"/>
+              <a:t>03</a:t>
+            </a:r>
+          </a:p>
+        </p:txBody>
+      </p:sp>
+      <p:sp>
+        <p:nvSpPr>
+          <p:cNvPr id="31" name="N3H"/>
+          <p:cNvSpPr>
+            <a:spLocks noGrp="1"/>
+          </p:cNvSpPr>
+          <p:nvPr>
+            <p:ph type="body" sz="quarter" idx="34"/>
+          </p:nvPr>
+        </p:nvSpPr>
+        <p:spPr/>
+        <p:txBody>
+          <a:bodyPr/>
+          <a:lstStyle/>
+          <a:p>
+            <a:r>
+              <a:rPr lang="en-AU" dirty="0"/>
+              <a:t>FedProx</a:t>
+            </a:r>
+          </a:p>
+        </p:txBody>
+      </p:sp>
+      <p:sp>
+        <p:nvSpPr>
+          <p:cNvPr id="32" name="N3B"/>
+          <p:cNvSpPr>
+            <a:spLocks noGrp="1"/>
+          </p:cNvSpPr>
+          <p:nvPr>
+            <p:ph type="body" sz="quarter" idx="35"/>
+          </p:nvPr>
+        </p:nvSpPr>
+        <p:spPr/>
+        <p:txBody>
+          <a:bodyPr/>
+          <a:lstStyle/>
+          <a:p>
+            <a:r>
+              <a:rPr lang="en-AU" dirty="0"/>
+              <a:t>Add proximal term; sweep α = 0.1, 0.5, 1.0 for both methods; tune μ</a:t>
+            </a:r>
+          </a:p>
+        </p:txBody>
+      </p:sp>
+      <p:sp>
+        <p:nvSpPr>
+          <p:cNvPr id="40" name="N4"/>
+          <p:cNvSpPr>
+            <a:spLocks noGrp="1"/>
+          </p:cNvSpPr>
+          <p:nvPr>
+            <p:ph type="body" sz="quarter" idx="36"/>
+          </p:nvPr>
+        </p:nvSpPr>
+        <p:spPr/>
+        <p:txBody>
+          <a:bodyPr/>
+          <a:lstStyle/>
+          <a:p>
+            <a:r>
+              <a:rPr lang="en-AU" dirty="0"/>
+              <a:t>04</a:t>
+            </a:r>
+          </a:p>
+        </p:txBody>
+      </p:sp>
+      <p:sp>
+        <p:nvSpPr>
+          <p:cNvPr id="41" name="N4H"/>
+          <p:cNvSpPr>
+            <a:spLocks noGrp="1"/>
+          </p:cNvSpPr>
+          <p:nvPr>
+            <p:ph type="body" sz="quarter" idx="37"/>
+          </p:nvPr>
+        </p:nvSpPr>
+        <p:spPr/>
+        <p:txBody>
+          <a:bodyPr/>
+          <a:lstStyle/>
+          <a:p>
+            <a:r>
+              <a:rPr lang="en-AU" dirty="0"/>
+              <a:t>Evaluation</a:t>
+            </a:r>
+          </a:p>
+        </p:txBody>
+      </p:sp>
+      <p:sp>
+        <p:nvSpPr>
+          <p:cNvPr id="42" name="N4B"/>
+          <p:cNvSpPr>
+            <a:spLocks noGrp="1"/>
+          </p:cNvSpPr>
+          <p:nvPr>
+            <p:ph type="body" sz="quarter" idx="38"/>
+          </p:nvPr>
+        </p:nvSpPr>
+        <p:spPr/>
+        <p:txBody>
+          <a:bodyPr/>
+          <a:lstStyle/>
+          <a:p>
+            <a:r>
+              <a:rPr lang="en-AU" dirty="0"/>
+              <a:t>Accuracy + macro F1 + communication rounds vs α; multiple seeds for statistical confidence</a:t>
+            </a:r>
+          </a:p>
+        </p:txBody>
+      </p:sp>
+      <p:sp>
+        <p:nvSpPr>
+          <p:cNvPr id="5" name="Text Placeholder 4">
+            <a:extLst>
+              <a:ext uri="{FF2B5EF4-FFF2-40B4-BE49-F238E27FC236}">
+                <a16:creationId xmlns:a16="http://schemas.microsoft.com/office/drawing/2014/main" id="{29396030-7728-3FAF-CF6A-CA1A7979A7BF}"/>
+              </a:ext>
+            </a:extLst>
+          </p:cNvPr>
+          <p:cNvSpPr>
+            <a:spLocks noGrp="1"/>
+          </p:cNvSpPr>
+          <p:nvPr>
+            <p:ph type="body" sz="quarter" idx="42"/>
+          </p:nvPr>
+        </p:nvSpPr>
+        <p:spPr/>
+        <p:txBody>
+          <a:bodyPr/>
+          <a:lstStyle/>
+          <a:p>
+            <a:endParaRPr lang="en-AU"/>
+          </a:p>
+        </p:txBody>
+      </p:sp>
+    </p:spTree>
+  </p:cSld>
+  <p:clrMapOvr>
+    <a:masterClrMapping/>
+  </p:clrMapOvr>
+</p:sld>
+</file>
+
+<file path=ppt/slides/slide15.xml><?xml version="1.0" encoding="utf-8"?>
+<p:sld xmlns:a="http://schemas.openxmlformats.org/drawingml/2006/main" xmlns:r="http://schemas.openxmlformats.org/officeDocument/2006/relationships" xmlns:p="http://schemas.openxmlformats.org/presentationml/2006/main">
+  <p:cSld>
+    <p:spTree>
+      <p:nvGrpSpPr>
+        <p:cNvPr id="1" name=""/>
+        <p:cNvGrpSpPr/>
+        <p:nvPr/>
+      </p:nvGrpSpPr>
+      <p:grpSpPr>
+        <a:xfrm>
+          <a:off x="0" y="0"/>
+          <a:ext cx="0" cy="0"/>
+          <a:chOff x="0" y="0"/>
+          <a:chExt cx="0" cy="0"/>
+        </a:xfrm>
+      </p:grpSpPr>
+      <p:sp>
+        <p:nvSpPr>
+          <p:cNvPr id="2" name="Title"/>
+          <p:cNvSpPr>
+            <a:spLocks noGrp="1"/>
+          </p:cNvSpPr>
+          <p:nvPr>
+            <p:ph type="title"/>
+          </p:nvPr>
+        </p:nvSpPr>
+        <p:spPr/>
+        <p:txBody>
+          <a:bodyPr/>
+          <a:lstStyle/>
+          <a:p>
+            <a:r>
+              <a:rPr lang="en-AU" dirty="0"/>
+              <a:t>Conclusion</a:t>
+            </a:r>
+          </a:p>
+        </p:txBody>
+      </p:sp>
+      <p:sp>
+        <p:nvSpPr>
+          <p:cNvPr id="4" name="LeftBody"/>
+          <p:cNvSpPr>
+            <a:spLocks noGrp="1"/>
+          </p:cNvSpPr>
+          <p:nvPr>
+            <p:ph idx="1"/>
+          </p:nvPr>
+        </p:nvSpPr>
+        <p:spPr>
+          <a:xfrm>
+            <a:off x="479425" y="2304629"/>
+            <a:ext cx="5616575" cy="3075932"/>
+          </a:xfrm>
+        </p:spPr>
+        <p:txBody>
+          <a:bodyPr/>
+          <a:lstStyle/>
+          <a:p>
+            <a:r>
+              <a:rPr lang="en-AU" dirty="0"/>
+              <a:t>Multi-class skin disease classification across hospitals is privacy-constrained; FedAvg breaks under non-IID, </a:t>
+            </a:r>
+            <a:r>
+              <a:rPr lang="en-AU" dirty="0" err="1"/>
+              <a:t>FedProx</a:t>
+            </a:r>
+            <a:r>
+              <a:rPr lang="en-AU" dirty="0"/>
+              <a:t> is proposed</a:t>
+            </a:r>
+          </a:p>
+          <a:p>
+            <a:r>
+              <a:rPr lang="en-AU" dirty="0"/>
+              <a:t>Both datasets characterised; sampling pipeline preserves class structure within 0.4%</a:t>
+            </a:r>
+          </a:p>
+          <a:p>
+            <a:r>
+              <a:rPr lang="en-AU" dirty="0"/>
+              <a:t>Centralised baseline running end-to-end; Dirichlet partitioning validated across α = 0.1, 0.5, 1.0</a:t>
+            </a:r>
+          </a:p>
+        </p:txBody>
+      </p:sp>
+      <p:sp>
+        <p:nvSpPr>
+          <p:cNvPr id="5" name="RightBlockText"/>
+          <p:cNvSpPr>
+            <a:spLocks noGrp="1"/>
+          </p:cNvSpPr>
+          <p:nvPr>
+            <p:ph type="body" sz="quarter" idx="14"/>
+          </p:nvPr>
+        </p:nvSpPr>
+        <p:spPr/>
+        <p:txBody>
+          <a:bodyPr/>
+          <a:lstStyle/>
+          <a:p>
+            <a:pPr>
+              <a:buNone/>
+            </a:pPr>
+            <a:r>
+              <a:rPr lang="en-AU" sz="2400" b="1" dirty="0"/>
+              <a:t>By the end of Semester 2:</a:t>
+            </a:r>
+          </a:p>
+          <a:p>
+            <a:pPr>
+              <a:buNone/>
+            </a:pPr>
+            <a:endParaRPr lang="en-AU" dirty="0"/>
+          </a:p>
+          <a:p>
+            <a:pPr>
+              <a:buNone/>
+            </a:pPr>
+            <a:r>
+              <a:rPr lang="en-AU" sz="1800" dirty="0"/>
+              <a:t>A answer to where FedProx beats FedAvg, by how much, and at what communication cost for fine-grained skin disease classification under realistic non-IID conditions</a:t>
+            </a:r>
+          </a:p>
+          <a:p>
+            <a:pPr>
+              <a:buNone/>
+            </a:pPr>
+            <a:endParaRPr lang="en-AU" dirty="0"/>
+          </a:p>
+          <a:p>
+            <a:pPr>
+              <a:buNone/>
+            </a:pPr>
+            <a:r>
+              <a:rPr lang="en-AU" sz="2400" b="1" dirty="0"/>
+              <a:t>Questions?</a:t>
+            </a:r>
+          </a:p>
+        </p:txBody>
+      </p:sp>
+    </p:spTree>
+  </p:cSld>
+  <p:clrMapOvr>
+    <a:masterClrMapping/>
+  </p:clrMapOvr>
 </p:sld>
 </file>
 
@@ -24528,16 +24985,11 @@
           </p:cNvGraphicFramePr>
           <p:nvPr>
             <p:ph type="tbl" sz="quarter" idx="12"/>
-            <p:extLst>
-              <p:ext uri="{D42A27DB-BD31-4B8C-83A1-F6EECF244321}">
-                <p14:modId xmlns:p14="http://schemas.microsoft.com/office/powerpoint/2010/main" val="1203921393"/>
-              </p:ext>
-            </p:extLst>
           </p:nvPr>
         </p:nvGraphicFramePr>
         <p:xfrm>
           <a:off x="498475" y="1628775"/>
-          <a:ext cx="5616573" cy="4469810"/>
+          <a:ext cx="5616573" cy="2681886"/>
         </p:xfrm>
         <a:graphic>
           <a:graphicData uri="http://schemas.openxmlformats.org/drawingml/2006/table">
@@ -24631,7 +25083,7 @@
                         <a:rPr lang="en-US" sz="1200" dirty="0">
                           <a:latin typeface="+mn-lt"/>
                         </a:rPr>
-                        <a:t>Lorem ipsum </a:t>
+                        <a:t>Motivation</a:t>
                       </a:r>
                     </a:p>
                   </a:txBody>
@@ -24669,15 +25121,7 @@
                         <a:tabLst/>
                         <a:defRPr/>
                       </a:pPr>
-                      <a:r>
-                        <a:rPr lang="en-US" sz="800" dirty="0">
-                          <a:solidFill>
-                            <a:schemeClr val="tx2"/>
-                          </a:solidFill>
-                          <a:latin typeface="+mn-lt"/>
-                        </a:rPr>
-                        <a:t>P. XX</a:t>
-                      </a:r>
+                      <a:endParaRPr/>
                     </a:p>
                   </a:txBody>
                   <a:tcPr anchor="ctr">
@@ -24779,7 +25223,7 @@
                           <a:uFillTx/>
                           <a:latin typeface="+mn-lt"/>
                         </a:rPr>
-                        <a:t>Lorem ipsum </a:t>
+                        <a:t>Background &amp; Methods</a:t>
                       </a:r>
                       <a:endParaRPr kumimoji="0" lang="en-US" sz="1200" b="0" i="0" u="none" strike="noStrike" kern="1200" cap="none" spc="0" normalizeH="0" baseline="0" noProof="0" dirty="0">
                         <a:ln>
@@ -24840,21 +25284,6 @@
                         <a:tabLst/>
                         <a:defRPr/>
                       </a:pPr>
-                      <a:r>
-                        <a:rPr kumimoji="0" lang="en-US" sz="800" b="1" u="none" strike="noStrike" kern="1200" cap="none" spc="0" normalizeH="0" baseline="0" noProof="0" dirty="0">
-                          <a:ln>
-                            <a:noFill/>
-                          </a:ln>
-                          <a:solidFill>
-                            <a:schemeClr val="tx2"/>
-                          </a:solidFill>
-                          <a:effectLst/>
-                          <a:uLnTx/>
-                          <a:uFillTx/>
-                          <a:latin typeface="+mn-lt"/>
-                        </a:rPr>
-                        <a:t>P. XX</a:t>
-                      </a:r>
                       <a:endParaRPr kumimoji="0" lang="en-US" sz="800" b="1" i="0" u="none" strike="noStrike" kern="1200" cap="none" spc="0" normalizeH="0" baseline="0" noProof="0" dirty="0">
                         <a:ln>
                           <a:noFill/>
@@ -24979,7 +25408,7 @@
                           <a:uFillTx/>
                           <a:latin typeface="+mn-lt"/>
                         </a:rPr>
-                        <a:t>Lorem ipsum </a:t>
+                        <a:t>Knowledge Gap</a:t>
                       </a:r>
                       <a:endParaRPr kumimoji="0" lang="en-US" sz="1200" b="0" i="0" u="none" strike="noStrike" kern="1200" cap="none" spc="0" normalizeH="0" baseline="0" noProof="0" dirty="0">
                         <a:ln>
@@ -25040,21 +25469,6 @@
                         <a:tabLst/>
                         <a:defRPr/>
                       </a:pPr>
-                      <a:r>
-                        <a:rPr kumimoji="0" lang="en-US" sz="800" b="1" u="none" strike="noStrike" kern="1200" cap="none" spc="0" normalizeH="0" baseline="0" noProof="0" dirty="0">
-                          <a:ln>
-                            <a:noFill/>
-                          </a:ln>
-                          <a:solidFill>
-                            <a:schemeClr val="tx2"/>
-                          </a:solidFill>
-                          <a:effectLst/>
-                          <a:uLnTx/>
-                          <a:uFillTx/>
-                          <a:latin typeface="+mn-lt"/>
-                        </a:rPr>
-                        <a:t>P. XX</a:t>
-                      </a:r>
                       <a:endParaRPr kumimoji="0" lang="en-US" sz="800" b="1" i="0" u="none" strike="noStrike" kern="1200" cap="none" spc="0" normalizeH="0" baseline="0" noProof="0" dirty="0">
                         <a:ln>
                           <a:noFill/>
@@ -25179,7 +25593,7 @@
                           <a:uFillTx/>
                           <a:latin typeface="+mn-lt"/>
                         </a:rPr>
-                        <a:t>Lorem ipsum </a:t>
+                        <a:t>Project Aim</a:t>
                       </a:r>
                       <a:endParaRPr kumimoji="0" lang="en-US" sz="1200" b="0" i="0" u="none" strike="noStrike" kern="1200" cap="none" spc="0" normalizeH="0" baseline="0" noProof="0" dirty="0">
                         <a:ln>
@@ -25240,21 +25654,6 @@
                         <a:tabLst/>
                         <a:defRPr/>
                       </a:pPr>
-                      <a:r>
-                        <a:rPr kumimoji="0" lang="en-US" sz="800" b="1" u="none" strike="noStrike" kern="1200" cap="none" spc="0" normalizeH="0" baseline="0" noProof="0" dirty="0">
-                          <a:ln>
-                            <a:noFill/>
-                          </a:ln>
-                          <a:solidFill>
-                            <a:schemeClr val="tx2"/>
-                          </a:solidFill>
-                          <a:effectLst/>
-                          <a:uLnTx/>
-                          <a:uFillTx/>
-                          <a:latin typeface="+mn-lt"/>
-                        </a:rPr>
-                        <a:t>P. XX</a:t>
-                      </a:r>
                       <a:endParaRPr kumimoji="0" lang="en-US" sz="800" b="1" i="0" u="none" strike="noStrike" kern="1200" cap="none" spc="0" normalizeH="0" baseline="0" noProof="0" dirty="0">
                         <a:ln>
                           <a:noFill/>
@@ -25379,7 +25778,7 @@
                           <a:uFillTx/>
                           <a:latin typeface="+mn-lt"/>
                         </a:rPr>
-                        <a:t>Lorem ipsum </a:t>
+                        <a:t>Progress</a:t>
                       </a:r>
                       <a:endParaRPr kumimoji="0" lang="en-US" sz="1200" b="0" i="0" u="none" strike="noStrike" kern="1200" cap="none" spc="0" normalizeH="0" baseline="0" noProof="0" dirty="0">
                         <a:ln>
@@ -25440,21 +25839,6 @@
                         <a:tabLst/>
                         <a:defRPr/>
                       </a:pPr>
-                      <a:r>
-                        <a:rPr kumimoji="0" lang="en-US" sz="800" b="1" u="none" strike="noStrike" kern="1200" cap="none" spc="0" normalizeH="0" baseline="0" noProof="0" dirty="0">
-                          <a:ln>
-                            <a:noFill/>
-                          </a:ln>
-                          <a:solidFill>
-                            <a:schemeClr val="tx2"/>
-                          </a:solidFill>
-                          <a:effectLst/>
-                          <a:uLnTx/>
-                          <a:uFillTx/>
-                          <a:latin typeface="+mn-lt"/>
-                        </a:rPr>
-                        <a:t>P. XX</a:t>
-                      </a:r>
                       <a:endParaRPr kumimoji="0" lang="en-US" sz="800" b="1" i="0" u="none" strike="noStrike" kern="1200" cap="none" spc="0" normalizeH="0" baseline="0" noProof="0" dirty="0">
                         <a:ln>
                           <a:noFill/>
@@ -25579,7 +25963,7 @@
                           <a:uFillTx/>
                           <a:latin typeface="+mn-lt"/>
                         </a:rPr>
-                        <a:t>Lorem ipsum </a:t>
+                        <a:t>Next Steps &amp; Conclusion</a:t>
                       </a:r>
                       <a:endParaRPr kumimoji="0" lang="en-US" sz="1200" b="0" i="0" u="none" strike="noStrike" kern="1200" cap="none" spc="0" normalizeH="0" baseline="0" noProof="0" dirty="0">
                         <a:ln>
@@ -25640,21 +26024,6 @@
                         <a:tabLst/>
                         <a:defRPr/>
                       </a:pPr>
-                      <a:r>
-                        <a:rPr kumimoji="0" lang="en-US" sz="800" b="1" u="none" strike="noStrike" kern="1200" cap="none" spc="0" normalizeH="0" baseline="0" noProof="0" dirty="0">
-                          <a:ln>
-                            <a:noFill/>
-                          </a:ln>
-                          <a:solidFill>
-                            <a:schemeClr val="tx2"/>
-                          </a:solidFill>
-                          <a:effectLst/>
-                          <a:uLnTx/>
-                          <a:uFillTx/>
-                          <a:latin typeface="+mn-lt"/>
-                        </a:rPr>
-                        <a:t>P. XX</a:t>
-                      </a:r>
                       <a:endParaRPr kumimoji="0" lang="en-US" sz="800" b="1" i="0" u="none" strike="noStrike" kern="1200" cap="none" spc="0" normalizeH="0" baseline="0" noProof="0" dirty="0">
                         <a:ln>
                           <a:noFill/>
@@ -25698,779 +26067,6 @@
                   </a:ext>
                 </a:extLst>
               </a:tr>
-              <a:tr h="446981">
-                <a:tc>
-                  <a:txBody>
-                    <a:bodyPr/>
-                    <a:lstStyle/>
-                    <a:p>
-                      <a:r>
-                        <a:rPr lang="en-US" sz="1400" kern="1200" dirty="0">
-                          <a:solidFill>
-                            <a:schemeClr val="accent1"/>
-                          </a:solidFill>
-                          <a:latin typeface="+mn-lt"/>
-                        </a:rPr>
-                        <a:t>07</a:t>
-                      </a:r>
-                      <a:endParaRPr lang="en-US" sz="1400" kern="1200" dirty="0">
-                        <a:solidFill>
-                          <a:schemeClr val="accent1"/>
-                        </a:solidFill>
-                        <a:latin typeface="+mn-lt"/>
-                        <a:ea typeface="+mn-ea"/>
-                        <a:cs typeface="+mn-cs"/>
-                      </a:endParaRPr>
-                    </a:p>
-                  </a:txBody>
-                  <a:tcPr anchor="ctr">
-                    <a:lnT w="12700" cap="flat" cmpd="sng" algn="ctr">
-                      <a:solidFill>
-                        <a:schemeClr val="bg2"/>
-                      </a:solidFill>
-                      <a:prstDash val="solid"/>
-                      <a:round/>
-                      <a:headEnd type="none" w="med" len="med"/>
-                      <a:tailEnd type="none" w="med" len="med"/>
-                    </a:lnT>
-                    <a:lnB w="12700" cap="flat" cmpd="sng" algn="ctr">
-                      <a:solidFill>
-                        <a:schemeClr val="bg2"/>
-                      </a:solidFill>
-                      <a:prstDash val="solid"/>
-                      <a:round/>
-                      <a:headEnd type="none" w="med" len="med"/>
-                      <a:tailEnd type="none" w="med" len="med"/>
-                    </a:lnB>
-                  </a:tcPr>
-                </a:tc>
-                <a:tc>
-                  <a:txBody>
-                    <a:bodyPr/>
-                    <a:lstStyle/>
-                    <a:p>
-                      <a:pPr marL="0" marR="0" lvl="0" indent="0" algn="l" defTabSz="914400" rtl="0" eaLnBrk="1" fontAlgn="auto" latinLnBrk="0" hangingPunct="1">
-                        <a:lnSpc>
-                          <a:spcPct val="100000"/>
-                        </a:lnSpc>
-                        <a:spcBef>
-                          <a:spcPts val="0"/>
-                        </a:spcBef>
-                        <a:spcAft>
-                          <a:spcPts val="0"/>
-                        </a:spcAft>
-                        <a:buClrTx/>
-                        <a:buSzTx/>
-                        <a:buFontTx/>
-                        <a:buNone/>
-                        <a:tabLst/>
-                        <a:defRPr/>
-                      </a:pPr>
-                      <a:r>
-                        <a:rPr kumimoji="0" lang="en-US" sz="1200" b="0" u="none" strike="noStrike" kern="1200" cap="none" spc="0" normalizeH="0" baseline="0" noProof="0" dirty="0">
-                          <a:ln>
-                            <a:noFill/>
-                          </a:ln>
-                          <a:solidFill>
-                            <a:srgbClr val="2B1D37"/>
-                          </a:solidFill>
-                          <a:effectLst/>
-                          <a:uLnTx/>
-                          <a:uFillTx/>
-                          <a:latin typeface="+mn-lt"/>
-                        </a:rPr>
-                        <a:t>Lorem ipsum </a:t>
-                      </a:r>
-                      <a:endParaRPr kumimoji="0" lang="en-US" sz="1200" b="0" i="0" u="none" strike="noStrike" kern="1200" cap="none" spc="0" normalizeH="0" baseline="0" noProof="0" dirty="0">
-                        <a:ln>
-                          <a:noFill/>
-                        </a:ln>
-                        <a:solidFill>
-                          <a:srgbClr val="2B1D37"/>
-                        </a:solidFill>
-                        <a:effectLst/>
-                        <a:uLnTx/>
-                        <a:uFillTx/>
-                        <a:latin typeface="+mn-lt"/>
-                        <a:ea typeface="+mn-ea"/>
-                        <a:cs typeface="+mn-cs"/>
-                      </a:endParaRPr>
-                    </a:p>
-                  </a:txBody>
-                  <a:tcPr anchor="ctr">
-                    <a:lnT w="12700" cap="flat" cmpd="sng" algn="ctr">
-                      <a:solidFill>
-                        <a:schemeClr val="bg2"/>
-                      </a:solidFill>
-                      <a:prstDash val="solid"/>
-                      <a:round/>
-                      <a:headEnd type="none" w="med" len="med"/>
-                      <a:tailEnd type="none" w="med" len="med"/>
-                    </a:lnT>
-                    <a:lnB w="12700" cap="flat" cmpd="sng" algn="ctr">
-                      <a:solidFill>
-                        <a:schemeClr val="bg2"/>
-                      </a:solidFill>
-                      <a:prstDash val="solid"/>
-                      <a:round/>
-                      <a:headEnd type="none" w="med" len="med"/>
-                      <a:tailEnd type="none" w="med" len="med"/>
-                    </a:lnB>
-                  </a:tcPr>
-                </a:tc>
-                <a:tc>
-                  <a:txBody>
-                    <a:bodyPr/>
-                    <a:lstStyle/>
-                    <a:p>
-                      <a:pPr marL="0" marR="0" lvl="0" indent="0" algn="r" defTabSz="914400" rtl="0" eaLnBrk="1" fontAlgn="auto" latinLnBrk="0" hangingPunct="1">
-                        <a:lnSpc>
-                          <a:spcPct val="100000"/>
-                        </a:lnSpc>
-                        <a:spcBef>
-                          <a:spcPts val="0"/>
-                        </a:spcBef>
-                        <a:spcAft>
-                          <a:spcPts val="0"/>
-                        </a:spcAft>
-                        <a:buClrTx/>
-                        <a:buSzTx/>
-                        <a:buFontTx/>
-                        <a:buNone/>
-                        <a:tabLst/>
-                        <a:defRPr/>
-                      </a:pPr>
-                      <a:r>
-                        <a:rPr kumimoji="0" lang="en-US" sz="800" b="1" u="none" strike="noStrike" kern="1200" cap="none" spc="0" normalizeH="0" baseline="0" noProof="0" dirty="0">
-                          <a:ln>
-                            <a:noFill/>
-                          </a:ln>
-                          <a:solidFill>
-                            <a:schemeClr val="tx2"/>
-                          </a:solidFill>
-                          <a:effectLst/>
-                          <a:uLnTx/>
-                          <a:uFillTx/>
-                          <a:latin typeface="+mn-lt"/>
-                        </a:rPr>
-                        <a:t>P. XX</a:t>
-                      </a:r>
-                      <a:endParaRPr kumimoji="0" lang="en-US" sz="800" b="1" i="0" u="none" strike="noStrike" kern="1200" cap="none" spc="0" normalizeH="0" baseline="0" noProof="0" dirty="0">
-                        <a:ln>
-                          <a:noFill/>
-                        </a:ln>
-                        <a:solidFill>
-                          <a:schemeClr val="tx2"/>
-                        </a:solidFill>
-                        <a:effectLst/>
-                        <a:uLnTx/>
-                        <a:uFillTx/>
-                        <a:latin typeface="+mn-lt"/>
-                        <a:ea typeface="+mn-ea"/>
-                        <a:cs typeface="+mn-cs"/>
-                      </a:endParaRPr>
-                    </a:p>
-                  </a:txBody>
-                  <a:tcPr anchor="ctr">
-                    <a:lnT w="12700" cap="flat" cmpd="sng" algn="ctr">
-                      <a:solidFill>
-                        <a:schemeClr val="bg2"/>
-                      </a:solidFill>
-                      <a:prstDash val="solid"/>
-                      <a:round/>
-                      <a:headEnd type="none" w="med" len="med"/>
-                      <a:tailEnd type="none" w="med" len="med"/>
-                    </a:lnT>
-                    <a:lnB w="12700" cap="flat" cmpd="sng" algn="ctr">
-                      <a:solidFill>
-                        <a:schemeClr val="bg2"/>
-                      </a:solidFill>
-                      <a:prstDash val="solid"/>
-                      <a:round/>
-                      <a:headEnd type="none" w="med" len="med"/>
-                      <a:tailEnd type="none" w="med" len="med"/>
-                    </a:lnB>
-                  </a:tcPr>
-                </a:tc>
-                <a:extLst>
-                  <a:ext uri="{0D108BD9-81ED-4DB2-BD59-A6C34878D82A}">
-                    <a16:rowId xmlns:a16="http://schemas.microsoft.com/office/drawing/2014/main" val="3712052663"/>
-                  </a:ext>
-                </a:extLst>
-              </a:tr>
-              <a:tr h="446981">
-                <a:tc>
-                  <a:txBody>
-                    <a:bodyPr/>
-                    <a:lstStyle/>
-                    <a:p>
-                      <a:r>
-                        <a:rPr lang="en-US" sz="1400" kern="1200" dirty="0">
-                          <a:solidFill>
-                            <a:schemeClr val="accent1"/>
-                          </a:solidFill>
-                          <a:latin typeface="+mn-lt"/>
-                        </a:rPr>
-                        <a:t>08</a:t>
-                      </a:r>
-                      <a:endParaRPr lang="en-US" sz="1400" kern="1200" dirty="0">
-                        <a:solidFill>
-                          <a:schemeClr val="accent1"/>
-                        </a:solidFill>
-                        <a:latin typeface="+mn-lt"/>
-                        <a:ea typeface="+mn-ea"/>
-                        <a:cs typeface="+mn-cs"/>
-                      </a:endParaRPr>
-                    </a:p>
-                  </a:txBody>
-                  <a:tcPr anchor="ctr">
-                    <a:lnT w="12700" cap="flat" cmpd="sng" algn="ctr">
-                      <a:solidFill>
-                        <a:schemeClr val="bg2"/>
-                      </a:solidFill>
-                      <a:prstDash val="solid"/>
-                      <a:round/>
-                      <a:headEnd type="none" w="med" len="med"/>
-                      <a:tailEnd type="none" w="med" len="med"/>
-                    </a:lnT>
-                    <a:lnB w="12700" cap="flat" cmpd="sng" algn="ctr">
-                      <a:solidFill>
-                        <a:schemeClr val="bg2"/>
-                      </a:solidFill>
-                      <a:prstDash val="solid"/>
-                      <a:round/>
-                      <a:headEnd type="none" w="med" len="med"/>
-                      <a:tailEnd type="none" w="med" len="med"/>
-                    </a:lnB>
-                  </a:tcPr>
-                </a:tc>
-                <a:tc>
-                  <a:txBody>
-                    <a:bodyPr/>
-                    <a:lstStyle/>
-                    <a:p>
-                      <a:pPr marL="0" marR="0" lvl="0" indent="0" algn="l" defTabSz="914400" rtl="0" eaLnBrk="1" fontAlgn="auto" latinLnBrk="0" hangingPunct="1">
-                        <a:lnSpc>
-                          <a:spcPct val="100000"/>
-                        </a:lnSpc>
-                        <a:spcBef>
-                          <a:spcPts val="0"/>
-                        </a:spcBef>
-                        <a:spcAft>
-                          <a:spcPts val="0"/>
-                        </a:spcAft>
-                        <a:buClrTx/>
-                        <a:buSzTx/>
-                        <a:buFontTx/>
-                        <a:buNone/>
-                        <a:tabLst/>
-                        <a:defRPr/>
-                      </a:pPr>
-                      <a:r>
-                        <a:rPr kumimoji="0" lang="en-US" sz="1200" b="0" u="none" strike="noStrike" kern="1200" cap="none" spc="0" normalizeH="0" baseline="0" noProof="0" dirty="0">
-                          <a:ln>
-                            <a:noFill/>
-                          </a:ln>
-                          <a:solidFill>
-                            <a:srgbClr val="2B1D37"/>
-                          </a:solidFill>
-                          <a:effectLst/>
-                          <a:uLnTx/>
-                          <a:uFillTx/>
-                          <a:latin typeface="+mn-lt"/>
-                        </a:rPr>
-                        <a:t>Lorem ipsum </a:t>
-                      </a:r>
-                      <a:endParaRPr kumimoji="0" lang="en-US" sz="1200" b="0" i="0" u="none" strike="noStrike" kern="1200" cap="none" spc="0" normalizeH="0" baseline="0" noProof="0" dirty="0">
-                        <a:ln>
-                          <a:noFill/>
-                        </a:ln>
-                        <a:solidFill>
-                          <a:srgbClr val="2B1D37"/>
-                        </a:solidFill>
-                        <a:effectLst/>
-                        <a:uLnTx/>
-                        <a:uFillTx/>
-                        <a:latin typeface="+mn-lt"/>
-                        <a:ea typeface="+mn-ea"/>
-                        <a:cs typeface="+mn-cs"/>
-                      </a:endParaRPr>
-                    </a:p>
-                  </a:txBody>
-                  <a:tcPr anchor="ctr">
-                    <a:lnT w="12700" cap="flat" cmpd="sng" algn="ctr">
-                      <a:solidFill>
-                        <a:schemeClr val="bg2"/>
-                      </a:solidFill>
-                      <a:prstDash val="solid"/>
-                      <a:round/>
-                      <a:headEnd type="none" w="med" len="med"/>
-                      <a:tailEnd type="none" w="med" len="med"/>
-                    </a:lnT>
-                    <a:lnB w="12700" cap="flat" cmpd="sng" algn="ctr">
-                      <a:solidFill>
-                        <a:schemeClr val="bg2"/>
-                      </a:solidFill>
-                      <a:prstDash val="solid"/>
-                      <a:round/>
-                      <a:headEnd type="none" w="med" len="med"/>
-                      <a:tailEnd type="none" w="med" len="med"/>
-                    </a:lnB>
-                  </a:tcPr>
-                </a:tc>
-                <a:tc>
-                  <a:txBody>
-                    <a:bodyPr/>
-                    <a:lstStyle/>
-                    <a:p>
-                      <a:pPr marL="0" marR="0" lvl="0" indent="0" algn="r" defTabSz="914400" rtl="0" eaLnBrk="1" fontAlgn="auto" latinLnBrk="0" hangingPunct="1">
-                        <a:lnSpc>
-                          <a:spcPct val="100000"/>
-                        </a:lnSpc>
-                        <a:spcBef>
-                          <a:spcPts val="0"/>
-                        </a:spcBef>
-                        <a:spcAft>
-                          <a:spcPts val="0"/>
-                        </a:spcAft>
-                        <a:buClrTx/>
-                        <a:buSzTx/>
-                        <a:buFontTx/>
-                        <a:buNone/>
-                        <a:tabLst/>
-                        <a:defRPr/>
-                      </a:pPr>
-                      <a:r>
-                        <a:rPr kumimoji="0" lang="en-US" sz="800" b="1" u="none" strike="noStrike" kern="1200" cap="none" spc="0" normalizeH="0" baseline="0" noProof="0" dirty="0">
-                          <a:ln>
-                            <a:noFill/>
-                          </a:ln>
-                          <a:solidFill>
-                            <a:schemeClr val="tx2"/>
-                          </a:solidFill>
-                          <a:effectLst/>
-                          <a:uLnTx/>
-                          <a:uFillTx/>
-                          <a:latin typeface="+mn-lt"/>
-                        </a:rPr>
-                        <a:t>P. XX</a:t>
-                      </a:r>
-                      <a:endParaRPr kumimoji="0" lang="en-US" sz="800" b="1" i="0" u="none" strike="noStrike" kern="1200" cap="none" spc="0" normalizeH="0" baseline="0" noProof="0" dirty="0">
-                        <a:ln>
-                          <a:noFill/>
-                        </a:ln>
-                        <a:solidFill>
-                          <a:schemeClr val="tx2"/>
-                        </a:solidFill>
-                        <a:effectLst/>
-                        <a:uLnTx/>
-                        <a:uFillTx/>
-                        <a:latin typeface="+mn-lt"/>
-                        <a:ea typeface="+mn-ea"/>
-                        <a:cs typeface="+mn-cs"/>
-                      </a:endParaRPr>
-                    </a:p>
-                  </a:txBody>
-                  <a:tcPr anchor="ctr">
-                    <a:lnT w="12700" cap="flat" cmpd="sng" algn="ctr">
-                      <a:solidFill>
-                        <a:schemeClr val="bg2"/>
-                      </a:solidFill>
-                      <a:prstDash val="solid"/>
-                      <a:round/>
-                      <a:headEnd type="none" w="med" len="med"/>
-                      <a:tailEnd type="none" w="med" len="med"/>
-                    </a:lnT>
-                    <a:lnB w="12700" cap="flat" cmpd="sng" algn="ctr">
-                      <a:solidFill>
-                        <a:schemeClr val="bg2"/>
-                      </a:solidFill>
-                      <a:prstDash val="solid"/>
-                      <a:round/>
-                      <a:headEnd type="none" w="med" len="med"/>
-                      <a:tailEnd type="none" w="med" len="med"/>
-                    </a:lnB>
-                  </a:tcPr>
-                </a:tc>
-                <a:extLst>
-                  <a:ext uri="{0D108BD9-81ED-4DB2-BD59-A6C34878D82A}">
-                    <a16:rowId xmlns:a16="http://schemas.microsoft.com/office/drawing/2014/main" val="2343404345"/>
-                  </a:ext>
-                </a:extLst>
-              </a:tr>
-              <a:tr h="446981">
-                <a:tc>
-                  <a:txBody>
-                    <a:bodyPr/>
-                    <a:lstStyle/>
-                    <a:p>
-                      <a:r>
-                        <a:rPr lang="en-US" sz="1400" kern="1200" dirty="0">
-                          <a:solidFill>
-                            <a:schemeClr val="accent1"/>
-                          </a:solidFill>
-                          <a:latin typeface="+mn-lt"/>
-                        </a:rPr>
-                        <a:t>09</a:t>
-                      </a:r>
-                      <a:endParaRPr lang="en-US" sz="1400" kern="1200" dirty="0">
-                        <a:solidFill>
-                          <a:schemeClr val="accent1"/>
-                        </a:solidFill>
-                        <a:latin typeface="+mn-lt"/>
-                        <a:ea typeface="+mn-ea"/>
-                        <a:cs typeface="+mn-cs"/>
-                      </a:endParaRPr>
-                    </a:p>
-                  </a:txBody>
-                  <a:tcPr anchor="ctr">
-                    <a:lnT w="12700" cap="flat" cmpd="sng" algn="ctr">
-                      <a:solidFill>
-                        <a:schemeClr val="bg2"/>
-                      </a:solidFill>
-                      <a:prstDash val="solid"/>
-                      <a:round/>
-                      <a:headEnd type="none" w="med" len="med"/>
-                      <a:tailEnd type="none" w="med" len="med"/>
-                    </a:lnT>
-                    <a:lnB w="12700" cap="flat" cmpd="sng" algn="ctr">
-                      <a:solidFill>
-                        <a:schemeClr val="bg2"/>
-                      </a:solidFill>
-                      <a:prstDash val="solid"/>
-                      <a:round/>
-                      <a:headEnd type="none" w="med" len="med"/>
-                      <a:tailEnd type="none" w="med" len="med"/>
-                    </a:lnB>
-                  </a:tcPr>
-                </a:tc>
-                <a:tc>
-                  <a:txBody>
-                    <a:bodyPr/>
-                    <a:lstStyle/>
-                    <a:p>
-                      <a:pPr marL="0" marR="0" lvl="0" indent="0" algn="l" defTabSz="914400" rtl="0" eaLnBrk="1" fontAlgn="auto" latinLnBrk="0" hangingPunct="1">
-                        <a:lnSpc>
-                          <a:spcPct val="100000"/>
-                        </a:lnSpc>
-                        <a:spcBef>
-                          <a:spcPts val="0"/>
-                        </a:spcBef>
-                        <a:spcAft>
-                          <a:spcPts val="0"/>
-                        </a:spcAft>
-                        <a:buClrTx/>
-                        <a:buSzTx/>
-                        <a:buFontTx/>
-                        <a:buNone/>
-                        <a:tabLst/>
-                        <a:defRPr/>
-                      </a:pPr>
-                      <a:r>
-                        <a:rPr kumimoji="0" lang="en-US" sz="1200" b="0" u="none" strike="noStrike" kern="1200" cap="none" spc="0" normalizeH="0" baseline="0" noProof="0" dirty="0">
-                          <a:ln>
-                            <a:noFill/>
-                          </a:ln>
-                          <a:solidFill>
-                            <a:srgbClr val="2B1D37"/>
-                          </a:solidFill>
-                          <a:effectLst/>
-                          <a:uLnTx/>
-                          <a:uFillTx/>
-                          <a:latin typeface="+mn-lt"/>
-                        </a:rPr>
-                        <a:t>Lorem ipsum </a:t>
-                      </a:r>
-                      <a:endParaRPr kumimoji="0" lang="en-US" sz="1200" b="0" i="0" u="none" strike="noStrike" kern="1200" cap="none" spc="0" normalizeH="0" baseline="0" noProof="0" dirty="0">
-                        <a:ln>
-                          <a:noFill/>
-                        </a:ln>
-                        <a:solidFill>
-                          <a:srgbClr val="2B1D37"/>
-                        </a:solidFill>
-                        <a:effectLst/>
-                        <a:uLnTx/>
-                        <a:uFillTx/>
-                        <a:latin typeface="+mn-lt"/>
-                        <a:ea typeface="+mn-ea"/>
-                        <a:cs typeface="+mn-cs"/>
-                      </a:endParaRPr>
-                    </a:p>
-                  </a:txBody>
-                  <a:tcPr anchor="ctr">
-                    <a:lnT w="12700" cap="flat" cmpd="sng" algn="ctr">
-                      <a:solidFill>
-                        <a:schemeClr val="bg2"/>
-                      </a:solidFill>
-                      <a:prstDash val="solid"/>
-                      <a:round/>
-                      <a:headEnd type="none" w="med" len="med"/>
-                      <a:tailEnd type="none" w="med" len="med"/>
-                    </a:lnT>
-                    <a:lnB w="12700" cap="flat" cmpd="sng" algn="ctr">
-                      <a:solidFill>
-                        <a:schemeClr val="bg2"/>
-                      </a:solidFill>
-                      <a:prstDash val="solid"/>
-                      <a:round/>
-                      <a:headEnd type="none" w="med" len="med"/>
-                      <a:tailEnd type="none" w="med" len="med"/>
-                    </a:lnB>
-                  </a:tcPr>
-                </a:tc>
-                <a:tc>
-                  <a:txBody>
-                    <a:bodyPr/>
-                    <a:lstStyle/>
-                    <a:p>
-                      <a:pPr marL="0" marR="0" lvl="0" indent="0" algn="r" defTabSz="914400" rtl="0" eaLnBrk="1" fontAlgn="auto" latinLnBrk="0" hangingPunct="1">
-                        <a:lnSpc>
-                          <a:spcPct val="100000"/>
-                        </a:lnSpc>
-                        <a:spcBef>
-                          <a:spcPts val="0"/>
-                        </a:spcBef>
-                        <a:spcAft>
-                          <a:spcPts val="0"/>
-                        </a:spcAft>
-                        <a:buClrTx/>
-                        <a:buSzTx/>
-                        <a:buFontTx/>
-                        <a:buNone/>
-                        <a:tabLst/>
-                        <a:defRPr/>
-                      </a:pPr>
-                      <a:r>
-                        <a:rPr kumimoji="0" lang="en-US" sz="800" b="1" u="none" strike="noStrike" kern="1200" cap="none" spc="0" normalizeH="0" baseline="0" noProof="0" dirty="0">
-                          <a:ln>
-                            <a:noFill/>
-                          </a:ln>
-                          <a:solidFill>
-                            <a:schemeClr val="tx2"/>
-                          </a:solidFill>
-                          <a:effectLst/>
-                          <a:uLnTx/>
-                          <a:uFillTx/>
-                          <a:latin typeface="+mn-lt"/>
-                        </a:rPr>
-                        <a:t>P. XX</a:t>
-                      </a:r>
-                      <a:endParaRPr kumimoji="0" lang="en-US" sz="800" b="1" i="0" u="none" strike="noStrike" kern="1200" cap="none" spc="0" normalizeH="0" baseline="0" noProof="0" dirty="0">
-                        <a:ln>
-                          <a:noFill/>
-                        </a:ln>
-                        <a:solidFill>
-                          <a:schemeClr val="tx2"/>
-                        </a:solidFill>
-                        <a:effectLst/>
-                        <a:uLnTx/>
-                        <a:uFillTx/>
-                        <a:latin typeface="+mn-lt"/>
-                        <a:ea typeface="+mn-ea"/>
-                        <a:cs typeface="+mn-cs"/>
-                      </a:endParaRPr>
-                    </a:p>
-                  </a:txBody>
-                  <a:tcPr anchor="ctr">
-                    <a:lnT w="12700" cap="flat" cmpd="sng" algn="ctr">
-                      <a:solidFill>
-                        <a:schemeClr val="bg2"/>
-                      </a:solidFill>
-                      <a:prstDash val="solid"/>
-                      <a:round/>
-                      <a:headEnd type="none" w="med" len="med"/>
-                      <a:tailEnd type="none" w="med" len="med"/>
-                    </a:lnT>
-                    <a:lnB w="12700" cap="flat" cmpd="sng" algn="ctr">
-                      <a:solidFill>
-                        <a:schemeClr val="bg2"/>
-                      </a:solidFill>
-                      <a:prstDash val="solid"/>
-                      <a:round/>
-                      <a:headEnd type="none" w="med" len="med"/>
-                      <a:tailEnd type="none" w="med" len="med"/>
-                    </a:lnB>
-                  </a:tcPr>
-                </a:tc>
-                <a:extLst>
-                  <a:ext uri="{0D108BD9-81ED-4DB2-BD59-A6C34878D82A}">
-                    <a16:rowId xmlns:a16="http://schemas.microsoft.com/office/drawing/2014/main" val="3830777568"/>
-                  </a:ext>
-                </a:extLst>
-              </a:tr>
-              <a:tr h="446981">
-                <a:tc>
-                  <a:txBody>
-                    <a:bodyPr/>
-                    <a:lstStyle/>
-                    <a:p>
-                      <a:r>
-                        <a:rPr lang="en-US" sz="1400" kern="1200" dirty="0">
-                          <a:solidFill>
-                            <a:schemeClr val="accent1"/>
-                          </a:solidFill>
-                          <a:latin typeface="+mn-lt"/>
-                        </a:rPr>
-                        <a:t>10</a:t>
-                      </a:r>
-                      <a:endParaRPr lang="en-US" sz="1400" kern="1200" dirty="0">
-                        <a:solidFill>
-                          <a:schemeClr val="accent1"/>
-                        </a:solidFill>
-                        <a:latin typeface="+mn-lt"/>
-                        <a:ea typeface="+mn-ea"/>
-                        <a:cs typeface="+mn-cs"/>
-                      </a:endParaRPr>
-                    </a:p>
-                  </a:txBody>
-                  <a:tcPr anchor="ctr">
-                    <a:lnT w="12700" cap="flat" cmpd="sng" algn="ctr">
-                      <a:solidFill>
-                        <a:schemeClr val="bg2"/>
-                      </a:solidFill>
-                      <a:prstDash val="solid"/>
-                      <a:round/>
-                      <a:headEnd type="none" w="med" len="med"/>
-                      <a:tailEnd type="none" w="med" len="med"/>
-                    </a:lnT>
-                  </a:tcPr>
-                </a:tc>
-                <a:tc>
-                  <a:txBody>
-                    <a:bodyPr/>
-                    <a:lstStyle/>
-                    <a:p>
-                      <a:pPr marL="0" marR="0" lvl="0" indent="0" algn="l" defTabSz="914400" rtl="0" eaLnBrk="1" fontAlgn="auto" latinLnBrk="0" hangingPunct="1">
-                        <a:lnSpc>
-                          <a:spcPct val="100000"/>
-                        </a:lnSpc>
-                        <a:spcBef>
-                          <a:spcPts val="0"/>
-                        </a:spcBef>
-                        <a:spcAft>
-                          <a:spcPts val="0"/>
-                        </a:spcAft>
-                        <a:buClrTx/>
-                        <a:buSzTx/>
-                        <a:buFontTx/>
-                        <a:buNone/>
-                        <a:tabLst/>
-                        <a:defRPr/>
-                      </a:pPr>
-                      <a:r>
-                        <a:rPr kumimoji="0" lang="en-US" sz="1200" b="0" u="none" strike="noStrike" kern="1200" cap="none" spc="0" normalizeH="0" baseline="0" noProof="0" dirty="0">
-                          <a:ln>
-                            <a:noFill/>
-                          </a:ln>
-                          <a:solidFill>
-                            <a:srgbClr val="2B1D37"/>
-                          </a:solidFill>
-                          <a:effectLst/>
-                          <a:uLnTx/>
-                          <a:uFillTx/>
-                          <a:latin typeface="+mn-lt"/>
-                        </a:rPr>
-                        <a:t>Lorem ipsum </a:t>
-                      </a:r>
-                      <a:endParaRPr kumimoji="0" lang="en-US" sz="1200" b="0" i="0" u="none" strike="noStrike" kern="1200" cap="none" spc="0" normalizeH="0" baseline="0" noProof="0" dirty="0">
-                        <a:ln>
-                          <a:noFill/>
-                        </a:ln>
-                        <a:solidFill>
-                          <a:srgbClr val="2B1D37"/>
-                        </a:solidFill>
-                        <a:effectLst/>
-                        <a:uLnTx/>
-                        <a:uFillTx/>
-                        <a:latin typeface="+mn-lt"/>
-                        <a:ea typeface="+mn-ea"/>
-                        <a:cs typeface="+mn-cs"/>
-                      </a:endParaRPr>
-                    </a:p>
-                  </a:txBody>
-                  <a:tcPr anchor="ctr">
-                    <a:lnT w="12700" cap="flat" cmpd="sng" algn="ctr">
-                      <a:solidFill>
-                        <a:schemeClr val="bg2"/>
-                      </a:solidFill>
-                      <a:prstDash val="solid"/>
-                      <a:round/>
-                      <a:headEnd type="none" w="med" len="med"/>
-                      <a:tailEnd type="none" w="med" len="med"/>
-                    </a:lnT>
-                  </a:tcPr>
-                </a:tc>
-                <a:tc>
-                  <a:txBody>
-                    <a:bodyPr/>
-                    <a:lstStyle/>
-                    <a:p>
-                      <a:pPr marL="0" marR="0" lvl="0" indent="0" algn="r" defTabSz="914400" rtl="0" eaLnBrk="1" fontAlgn="auto" latinLnBrk="0" hangingPunct="1">
-                        <a:lnSpc>
-                          <a:spcPct val="100000"/>
-                        </a:lnSpc>
-                        <a:spcBef>
-                          <a:spcPts val="0"/>
-                        </a:spcBef>
-                        <a:spcAft>
-                          <a:spcPts val="0"/>
-                        </a:spcAft>
-                        <a:buClrTx/>
-                        <a:buSzTx/>
-                        <a:buFontTx/>
-                        <a:buNone/>
-                        <a:tabLst/>
-                        <a:defRPr/>
-                      </a:pPr>
-                      <a:r>
-                        <a:rPr kumimoji="0" lang="en-US" sz="800" b="1" u="none" strike="noStrike" kern="1200" cap="none" spc="0" normalizeH="0" baseline="0" noProof="0" dirty="0">
-                          <a:ln>
-                            <a:noFill/>
-                          </a:ln>
-                          <a:solidFill>
-                            <a:schemeClr val="tx2"/>
-                          </a:solidFill>
-                          <a:effectLst/>
-                          <a:uLnTx/>
-                          <a:uFillTx/>
-                          <a:latin typeface="+mn-lt"/>
-                        </a:rPr>
-                        <a:t>P. XX</a:t>
-                      </a:r>
-                      <a:endParaRPr kumimoji="0" lang="en-US" sz="800" b="1" i="0" u="none" strike="noStrike" kern="1200" cap="none" spc="0" normalizeH="0" baseline="0" noProof="0" dirty="0">
-                        <a:ln>
-                          <a:noFill/>
-                        </a:ln>
-                        <a:solidFill>
-                          <a:schemeClr val="tx2"/>
-                        </a:solidFill>
-                        <a:effectLst/>
-                        <a:uLnTx/>
-                        <a:uFillTx/>
-                        <a:latin typeface="+mn-lt"/>
-                        <a:ea typeface="+mn-ea"/>
-                        <a:cs typeface="+mn-cs"/>
-                      </a:endParaRPr>
-                    </a:p>
-                  </a:txBody>
-                  <a:tcPr anchor="ctr">
-                    <a:lnT w="12700" cap="flat" cmpd="sng" algn="ctr">
-                      <a:solidFill>
-                        <a:schemeClr val="bg2"/>
-                      </a:solidFill>
-                      <a:prstDash val="solid"/>
-                      <a:round/>
-                      <a:headEnd type="none" w="med" len="med"/>
-                      <a:tailEnd type="none" w="med" len="med"/>
-                    </a:lnT>
-                  </a:tcPr>
-                </a:tc>
-                <a:extLst>
-                  <a:ext uri="{0D108BD9-81ED-4DB2-BD59-A6C34878D82A}">
-                    <a16:rowId xmlns:a16="http://schemas.microsoft.com/office/drawing/2014/main" val="1987778189"/>
-                  </a:ext>
-                </a:extLst>
-              </a:tr>
             </a:tbl>
           </a:graphicData>
         </a:graphic>
@@ -26561,7 +26157,7 @@
     </p:spTree>
     <p:extLst>
       <p:ext uri="{BB962C8B-B14F-4D97-AF65-F5344CB8AC3E}">
-        <p14:creationId xmlns:p14="http://schemas.microsoft.com/office/powerpoint/2010/main" val="387762459"/>
+        <p14:creationId xmlns:p14="http://schemas.microsoft.com/office/powerpoint/2010/main" val="2348456594"/>
       </p:ext>
     </p:extLst>
   </p:cSld>
@@ -27140,7 +26736,7 @@
           <a:p>
             <a:r>
               <a:rPr lang="en-AU" b="0" dirty="0"/>
-              <a:t>Skin diseases are among the most prevalent health conditions globally. [1]</a:t>
+              <a:t>Skin diseases are among the most prevalent health conditions globally [1].</a:t>
             </a:r>
           </a:p>
           <a:p>
@@ -28115,7 +27711,7 @@
           <a:p>
             <a:r>
               <a:rPr lang="en-AU" dirty="0"/>
-              <a:t>Practical trade-offs for clinical deployment</a:t>
+              <a:t>Practical trade-offs</a:t>
             </a:r>
           </a:p>
           <a:p>
@@ -28285,7 +27881,7 @@
           <p:cNvPr id="2" name="Content Placeholder 1">
             <a:extLst>
               <a:ext uri="{FF2B5EF4-FFF2-40B4-BE49-F238E27FC236}">
-                <a16:creationId xmlns:a16="http://schemas.microsoft.com/office/drawing/2014/main" id="{6B117025-6E8D-292E-F9A5-9FB6CB9D9598}"/>
+                <a16:creationId xmlns:a16="http://schemas.microsoft.com/office/drawing/2014/main" id="{EB4CD3C3-75B5-0D08-BE0C-9707CFFB0E08}"/>
               </a:ext>
             </a:extLst>
           </p:cNvPr>
@@ -28301,7 +27897,51 @@
           <a:bodyPr/>
           <a:lstStyle/>
           <a:p>
-            <a:endParaRPr lang="en-AU"/>
+            <a:r>
+              <a:rPr lang="en-AU" dirty="0"/>
+              <a:t>Where does FedProx beat FedAvg, and by how much?</a:t>
+            </a:r>
+          </a:p>
+          <a:p>
+            <a:pPr lvl="2"/>
+            <a:r>
+              <a:rPr lang="en-AU" dirty="0"/>
+              <a:t>Sweep Dirichlet α from extreme skew to near-IID; measure where the proximal term actually pays off</a:t>
+            </a:r>
+          </a:p>
+          <a:p>
+            <a:pPr lvl="2"/>
+            <a:endParaRPr lang="en-AU" dirty="0"/>
+          </a:p>
+          <a:p>
+            <a:r>
+              <a:rPr lang="en-AU" dirty="0"/>
+              <a:t>What does federated learning cost?</a:t>
+            </a:r>
+          </a:p>
+          <a:p>
+            <a:pPr lvl="2"/>
+            <a:r>
+              <a:rPr lang="en-AU" dirty="0"/>
+              <a:t>Communication rounds and parameter volume to reach centralised baseline accuracy</a:t>
+            </a:r>
+          </a:p>
+          <a:p>
+            <a:pPr lvl="2"/>
+            <a:endParaRPr lang="en-AU" dirty="0"/>
+          </a:p>
+          <a:p>
+            <a:r>
+              <a:rPr lang="en-AU" dirty="0"/>
+              <a:t>Where does federated learning fail first?</a:t>
+            </a:r>
+          </a:p>
+          <a:p>
+            <a:pPr lvl="2"/>
+            <a:r>
+              <a:rPr lang="en-AU" dirty="0"/>
+              <a:t>Whether overall accuracy or minority-class performance degrades earlier under heterogeneity</a:t>
+            </a:r>
           </a:p>
         </p:txBody>
       </p:sp>
@@ -28310,7 +27950,7 @@
           <p:cNvPr id="3" name="Title 2">
             <a:extLst>
               <a:ext uri="{FF2B5EF4-FFF2-40B4-BE49-F238E27FC236}">
-                <a16:creationId xmlns:a16="http://schemas.microsoft.com/office/drawing/2014/main" id="{E9F180F3-5417-6C8B-96C6-C6A697542B2D}"/>
+                <a16:creationId xmlns:a16="http://schemas.microsoft.com/office/drawing/2014/main" id="{2F932825-1320-3E12-4169-D586BD78CEE4}"/>
               </a:ext>
             </a:extLst>
           </p:cNvPr>
@@ -28338,7 +27978,7 @@
           <p:cNvPr id="4" name="Footer Placeholder 3">
             <a:extLst>
               <a:ext uri="{FF2B5EF4-FFF2-40B4-BE49-F238E27FC236}">
-                <a16:creationId xmlns:a16="http://schemas.microsoft.com/office/drawing/2014/main" id="{4476CB79-74A6-7049-4834-68DE8625A549}"/>
+                <a16:creationId xmlns:a16="http://schemas.microsoft.com/office/drawing/2014/main" id="{B51B6659-5B9B-5C96-1880-339667A3584E}"/>
               </a:ext>
             </a:extLst>
           </p:cNvPr>
@@ -28363,7 +28003,7 @@
           <p:cNvPr id="5" name="Slide Number Placeholder 4">
             <a:extLst>
               <a:ext uri="{FF2B5EF4-FFF2-40B4-BE49-F238E27FC236}">
-                <a16:creationId xmlns:a16="http://schemas.microsoft.com/office/drawing/2014/main" id="{C9E19B78-FCF7-0EB5-D23D-EBE55702C4AC}"/>
+                <a16:creationId xmlns:a16="http://schemas.microsoft.com/office/drawing/2014/main" id="{A321105B-EC78-425A-166B-E569C693D99C}"/>
               </a:ext>
             </a:extLst>
           </p:cNvPr>
@@ -28393,7 +28033,7 @@
           <p:cNvPr id="6" name="Text Placeholder 5">
             <a:extLst>
               <a:ext uri="{FF2B5EF4-FFF2-40B4-BE49-F238E27FC236}">
-                <a16:creationId xmlns:a16="http://schemas.microsoft.com/office/drawing/2014/main" id="{ED7728E2-DCB3-2CEC-D0A7-CF4AB1A4E92B}"/>
+                <a16:creationId xmlns:a16="http://schemas.microsoft.com/office/drawing/2014/main" id="{BA21B3BB-CA00-2E87-701E-958DDA390AE9}"/>
               </a:ext>
             </a:extLst>
           </p:cNvPr>
@@ -28409,14 +28049,17 @@
           <a:bodyPr/>
           <a:lstStyle/>
           <a:p>
-            <a:endParaRPr lang="en-AU"/>
+            <a:r>
+              <a:rPr lang="en-AU" dirty="0"/>
+              <a:t>Three questions this thesis is structured to answer</a:t>
+            </a:r>
           </a:p>
         </p:txBody>
       </p:sp>
     </p:spTree>
     <p:extLst>
       <p:ext uri="{BB962C8B-B14F-4D97-AF65-F5344CB8AC3E}">
-        <p14:creationId xmlns:p14="http://schemas.microsoft.com/office/powerpoint/2010/main" val="3631212267"/>
+        <p14:creationId xmlns:p14="http://schemas.microsoft.com/office/powerpoint/2010/main" val="3216997402"/>
       </p:ext>
     </p:extLst>
   </p:cSld>

</xml_diff>